<commit_message>
🔧 chore(day16): update weekly stock review deck with 0831 data
</commit_message>
<xml_diff>
--- a/iThome-2026-Ironman/Day16_20260830/Stock_Weekly_Review_20260824-0828.pptx
+++ b/iThome-2026-Ironman/Day16_20260830/Stock_Weekly_Review_20260824-0828.pptx
@@ -3282,7 +3282,7 @@
                 </a:solidFill>
                 <a:latin typeface="Consolas"/>
               </a:rPr>
-              <a:t>2026 / 08 / 24  —  08 / 28</a:t>
+              <a:t>2026 / 08 / 24  —  08 / 30</a:t>
             </a:r>
           </a:p>
           <a:p>
@@ -3301,7 +3301,7 @@
                 </a:solidFill>
                 <a:latin typeface="Microsoft JhengHei"/>
               </a:rPr>
-              <a:t>上週回顧　×　下週判斷</a:t>
+              <a:t>上週回顧　×　下週判斷　（含 08/29–08/30 週末節目）</a:t>
             </a:r>
           </a:p>
         </p:txBody>
@@ -3362,7 +3362,7 @@
                 </a:solidFill>
                 <a:latin typeface="Consolas"/>
               </a:rPr>
-              <a:t>5</a:t>
+              <a:t>6</a:t>
             </a:r>
           </a:p>
           <a:p>
@@ -3381,7 +3381,7 @@
                 </a:solidFill>
                 <a:latin typeface="Microsoft JhengHei"/>
               </a:rPr>
-              <a:t>個交易日的節目摘要檔</a:t>
+              <a:t>份摘要檔：五個交易日 ＋ 週末</a:t>
             </a:r>
           </a:p>
         </p:txBody>
@@ -3985,7 +3985,7 @@
         </p:nvGraphicFramePr>
         <p:xfrm>
           <a:off x="530352" y="1298448"/>
-          <a:ext cx="11128248" cy="2852928"/>
+          <a:ext cx="11128248" cy="3035808"/>
         </p:xfrm>
         <a:graphic>
           <a:graphicData uri="http://schemas.openxmlformats.org/drawingml/2006/table">
@@ -4093,7 +4093,7 @@
                   </a:tcPr>
                 </a:tc>
               </a:tr>
-              <a:tr h="512064">
+              <a:tr h="457200">
                 <a:tc>
                   <a:txBody>
                     <a:bodyPr/>
@@ -4187,7 +4187,7 @@
                   </a:tcPr>
                 </a:tc>
               </a:tr>
-              <a:tr h="512064">
+              <a:tr h="457200">
                 <a:tc>
                   <a:txBody>
                     <a:bodyPr/>
@@ -4281,7 +4281,7 @@
                   </a:tcPr>
                 </a:tc>
               </a:tr>
-              <a:tr h="512064">
+              <a:tr h="457200">
                 <a:tc>
                   <a:txBody>
                     <a:bodyPr/>
@@ -4375,7 +4375,7 @@
                   </a:tcPr>
                 </a:tc>
               </a:tr>
-              <a:tr h="512064">
+              <a:tr h="457200">
                 <a:tc>
                   <a:txBody>
                     <a:bodyPr/>
@@ -4469,7 +4469,7 @@
                   </a:tcPr>
                 </a:tc>
               </a:tr>
-              <a:tr h="512064">
+              <a:tr h="457200">
                 <a:tc>
                   <a:txBody>
                     <a:bodyPr/>
@@ -4563,6 +4563,100 @@
                   </a:tcPr>
                 </a:tc>
               </a:tr>
+              <a:tr h="457200">
+                <a:tc>
+                  <a:txBody>
+                    <a:bodyPr/>
+                    <a:lstStyle/>
+                    <a:p>
+                      <a:pPr algn="l"/>
+                      <a:r>
+                        <a:rPr sz="1250" b="1">
+                          <a:solidFill>
+                            <a:srgbClr val="101828"/>
+                          </a:solidFill>
+                          <a:latin typeface="Consolas"/>
+                        </a:rPr>
+                        <a:t>08/29–30 週末</a:t>
+                      </a:r>
+                    </a:p>
+                  </a:txBody>
+                  <a:tcPr marL="91440" marR="73152" marT="27432" marB="27432" anchor="ctr">
+                    <a:solidFill>
+                      <a:srgbClr val="F6F7F9"/>
+                    </a:solidFill>
+                  </a:tcPr>
+                </a:tc>
+                <a:tc>
+                  <a:txBody>
+                    <a:bodyPr/>
+                    <a:lstStyle/>
+                    <a:p>
+                      <a:pPr algn="l"/>
+                      <a:r>
+                        <a:rPr sz="1250" b="1">
+                          <a:solidFill>
+                            <a:srgbClr val="0F7A55"/>
+                          </a:solidFill>
+                          <a:latin typeface="Consolas"/>
+                        </a:rPr>
+                        <a:t>台指期夜盤急跌</a:t>
+                      </a:r>
+                    </a:p>
+                  </a:txBody>
+                  <a:tcPr marL="91440" marR="73152" marT="27432" marB="27432" anchor="ctr">
+                    <a:solidFill>
+                      <a:srgbClr val="F6F7F9"/>
+                    </a:solidFill>
+                  </a:tcPr>
+                </a:tc>
+                <a:tc>
+                  <a:txBody>
+                    <a:bodyPr/>
+                    <a:lstStyle/>
+                    <a:p>
+                      <a:pPr algn="l"/>
+                      <a:r>
+                        <a:rPr sz="1250" b="0">
+                          <a:solidFill>
+                            <a:srgbClr val="101828"/>
+                          </a:solidFill>
+                          <a:latin typeface="Microsoft JhengHei"/>
+                        </a:rPr>
+                        <a:t>8 月月成交量 17 兆（7 月 21 兆）</a:t>
+                      </a:r>
+                    </a:p>
+                  </a:txBody>
+                  <a:tcPr marL="91440" marR="73152" marT="27432" marB="27432" anchor="ctr">
+                    <a:solidFill>
+                      <a:srgbClr val="F6F7F9"/>
+                    </a:solidFill>
+                  </a:tcPr>
+                </a:tc>
+                <a:tc>
+                  <a:txBody>
+                    <a:bodyPr/>
+                    <a:lstStyle/>
+                    <a:p>
+                      <a:pPr algn="l"/>
+                      <a:r>
+                        <a:rPr sz="1250" b="0">
+                          <a:solidFill>
+                            <a:srgbClr val="101828"/>
+                          </a:solidFill>
+                          <a:latin typeface="Microsoft JhengHei"/>
+                        </a:rPr>
+                        <a:t>華許央行年會放鷹，9 月升息機率跳升，美股四大指數同步下跌</a:t>
+                      </a:r>
+                    </a:p>
+                  </a:txBody>
+                  <a:tcPr marL="91440" marR="73152" marT="27432" marB="27432" anchor="ctr">
+                    <a:solidFill>
+                      <a:srgbClr val="F6F7F9"/>
+                    </a:solidFill>
+                  </a:tcPr>
+                </a:tc>
+              </a:tr>
             </a:tbl>
           </a:graphicData>
         </a:graphic>
@@ -4575,8 +4669,8 @@
         </p:nvSpPr>
         <p:spPr>
           <a:xfrm>
-            <a:off x="530352" y="4498848"/>
-            <a:ext cx="11130991" cy="1207008"/>
+            <a:off x="530352" y="4443984"/>
+            <a:ext cx="11130991" cy="1280160"/>
           </a:xfrm>
           <a:prstGeom prst="rect">
             <a:avLst/>
@@ -4619,8 +4713,8 @@
         </p:nvSpPr>
         <p:spPr>
           <a:xfrm>
-            <a:off x="786384" y="4663440"/>
-            <a:ext cx="10618927" cy="914400"/>
+            <a:off x="786384" y="4590288"/>
+            <a:ext cx="10618927" cy="1005840"/>
           </a:xfrm>
           <a:prstGeom prst="rect">
             <a:avLst/>
@@ -4648,7 +4742,7 @@
                 </a:solidFill>
                 <a:latin typeface="Microsoft JhengHei"/>
               </a:rPr>
-              <a:t>週一恐慌新低量　→　週二尾盤反攻　→　週三資金回流電子　→　週四輝達利多但收上影線　→　週五量能過兆但未過前高</a:t>
+              <a:t>週一恐慌新低量　→　週二尾盤反攻　→　週三資金回流電子　→　週四輝達利多但收上影線　→　週五量能過兆　→　週末利率翻鷹</a:t>
             </a:r>
           </a:p>
           <a:p>
@@ -4667,7 +4761,7 @@
                 </a:solidFill>
                 <a:latin typeface="Microsoft JhengHei"/>
               </a:rPr>
-              <a:t>陳昆仁在週一即指出「新低量不等於新低價」，是主力量縮洗浮額；四天後大盤自低點漲逾 2,000 點。</a:t>
+              <a:t>陳昆仁在週一即指出「新低量不等於新低價」，是主力量縮洗浮額，四天後大盤自低點漲逾 2,000 點；但週末華許放鷹，把整週建立起來的降息預期又推翻一次。</a:t>
             </a:r>
           </a:p>
         </p:txBody>
@@ -4899,7 +4993,7 @@
                 </a:solidFill>
                 <a:latin typeface="Microsoft JhengHei"/>
               </a:rPr>
-              <a:t>總體環境：三個變數同時轉向</a:t>
+              <a:t>總體環境：利率預期一週轉兩次向</a:t>
             </a:r>
           </a:p>
         </p:txBody>
@@ -4941,7 +5035,7 @@
                 </a:solidFill>
                 <a:latin typeface="Microsoft JhengHei"/>
               </a:rPr>
-              <a:t>利率、油價、匯率</a:t>
+              <a:t>週初壓抑、週三放鬆、週末翻鷹</a:t>
             </a:r>
           </a:p>
         </p:txBody>
@@ -4955,7 +5049,7 @@
         <p:spPr>
           <a:xfrm>
             <a:off x="530352" y="1298448"/>
-            <a:ext cx="3675887" cy="2651760"/>
+            <a:ext cx="3675887" cy="2615184"/>
           </a:xfrm>
           <a:prstGeom prst="rect">
             <a:avLst/>
@@ -5005,7 +5099,7 @@
             <a:avLst/>
           </a:prstGeom>
           <a:solidFill>
-            <a:srgbClr val="0F7A55"/>
+            <a:srgbClr val="C1121F"/>
           </a:solidFill>
           <a:ln>
             <a:noFill/>
@@ -5042,7 +5136,7 @@
         </p:nvSpPr>
         <p:spPr>
           <a:xfrm>
-            <a:off x="749808" y="1481328"/>
+            <a:off x="749808" y="1463040"/>
             <a:ext cx="3236975" cy="2377440"/>
           </a:xfrm>
           <a:prstGeom prst="rect">
@@ -5061,7 +5155,7 @@
                 <a:spcPts val="0"/>
               </a:spcBef>
               <a:spcAft>
-                <a:spcPts val="800"/>
+                <a:spcPts val="700"/>
               </a:spcAft>
             </a:pPr>
             <a:r>
@@ -5071,7 +5165,7 @@
                 </a:solidFill>
                 <a:latin typeface="Microsoft JhengHei"/>
               </a:rPr>
-              <a:t>美債殖利率</a:t>
+              <a:t>美債與升息預期</a:t>
             </a:r>
           </a:p>
           <a:p>
@@ -5080,17 +5174,17 @@
                 <a:spcPts val="0"/>
               </a:spcBef>
               <a:spcAft>
-                <a:spcPts val="300"/>
-              </a:spcAft>
-            </a:pPr>
-            <a:r>
-              <a:rPr sz="1050" b="0">
+                <a:spcPts val="200"/>
+              </a:spcAft>
+            </a:pPr>
+            <a:r>
+              <a:rPr sz="1250" b="0">
                 <a:solidFill>
                   <a:srgbClr val="5B6472"/>
                 </a:solidFill>
                 <a:latin typeface="Microsoft JhengHei"/>
               </a:rPr>
-              <a:t>週初</a:t>
+              <a:t>週初 10 年期 4.73%、30 年期 5.27%</a:t>
             </a:r>
           </a:p>
           <a:p>
@@ -5103,32 +5197,13 @@
               </a:spcAft>
             </a:pPr>
             <a:r>
-              <a:rPr sz="1400" b="0">
-                <a:solidFill>
-                  <a:srgbClr val="101828"/>
-                </a:solidFill>
-                <a:latin typeface="Consolas"/>
-              </a:rPr>
-              <a:t>10 年期約 4.73%</a:t>
-            </a:r>
-          </a:p>
-          <a:p>
-            <a:pPr algn="l">
-              <a:spcBef>
-                <a:spcPts val="0"/>
-              </a:spcBef>
-              <a:spcAft>
-                <a:spcPts val="200"/>
-              </a:spcAft>
-            </a:pPr>
-            <a:r>
-              <a:rPr sz="1400" b="0">
-                <a:solidFill>
-                  <a:srgbClr val="101828"/>
-                </a:solidFill>
-                <a:latin typeface="Consolas"/>
-              </a:rPr>
-              <a:t>30 年期約 5.27%</a:t>
+              <a:rPr sz="1250" b="0">
+                <a:solidFill>
+                  <a:srgbClr val="5B6472"/>
+                </a:solidFill>
+                <a:latin typeface="Microsoft JhengHei"/>
+              </a:rPr>
+              <a:t>週三：財政部擴大回購，殖利率下滑</a:t>
             </a:r>
           </a:p>
           <a:p>
@@ -5143,11 +5218,11 @@
             <a:r>
               <a:rPr sz="1400" b="1">
                 <a:solidFill>
-                  <a:srgbClr val="0F7A55"/>
-                </a:solidFill>
-                <a:latin typeface="Microsoft JhengHei"/>
-              </a:rPr>
-              <a:t>↓　長天期殖利率下滑</a:t>
+                  <a:srgbClr val="C1121F"/>
+                </a:solidFill>
+                <a:latin typeface="Microsoft JhengHei"/>
+              </a:rPr>
+              <a:t>↑　週末翻鷹：9 月升息機率 35% → 60%</a:t>
             </a:r>
           </a:p>
           <a:p>
@@ -5166,7 +5241,7 @@
                 </a:solidFill>
                 <a:latin typeface="Microsoft JhengHei"/>
               </a:rPr>
-              <a:t>財政部擴大長債回購，規模約 1 兆美元；利率走跌有助高本益比成長股估值修復。</a:t>
+              <a:t>華許在央行年會演說偏鷹，兩年期美債殖利率跳升 11 個基點；陳昆仁稱市場已定價 57%。</a:t>
             </a:r>
           </a:p>
           <a:p>
@@ -5185,7 +5260,7 @@
                 </a:solidFill>
                 <a:latin typeface="Microsoft JhengHei"/>
               </a:rPr>
-              <a:t>游庭皓、林漢偉、容逸燊</a:t>
+              <a:t>林漢偉、陳昆仁、蔡明翰</a:t>
             </a:r>
           </a:p>
         </p:txBody>
@@ -5199,7 +5274,7 @@
         <p:spPr>
           <a:xfrm>
             <a:off x="4334256" y="1298448"/>
-            <a:ext cx="3675887" cy="2651760"/>
+            <a:ext cx="3675887" cy="2615184"/>
           </a:xfrm>
           <a:prstGeom prst="rect">
             <a:avLst/>
@@ -5286,7 +5361,7 @@
         </p:nvSpPr>
         <p:spPr>
           <a:xfrm>
-            <a:off x="4553712" y="1481328"/>
+            <a:off x="4553712" y="1463040"/>
             <a:ext cx="3236975" cy="2377440"/>
           </a:xfrm>
           <a:prstGeom prst="rect">
@@ -5305,7 +5380,7 @@
                 <a:spcPts val="0"/>
               </a:spcBef>
               <a:spcAft>
-                <a:spcPts val="800"/>
+                <a:spcPts val="700"/>
               </a:spcAft>
             </a:pPr>
             <a:r>
@@ -5324,17 +5399,17 @@
                 <a:spcPts val="0"/>
               </a:spcBef>
               <a:spcAft>
-                <a:spcPts val="300"/>
-              </a:spcAft>
-            </a:pPr>
-            <a:r>
-              <a:rPr sz="1050" b="0">
+                <a:spcPts val="200"/>
+              </a:spcAft>
+            </a:pPr>
+            <a:r>
+              <a:rPr sz="1250" b="0">
                 <a:solidFill>
                   <a:srgbClr val="5B6472"/>
                 </a:solidFill>
                 <a:latin typeface="Microsoft JhengHei"/>
               </a:rPr>
-              <a:t>週初</a:t>
+              <a:t>7 月 PCE 年增 3.7%、核心 3.3%</a:t>
             </a:r>
           </a:p>
           <a:p>
@@ -5347,32 +5422,13 @@
               </a:spcAft>
             </a:pPr>
             <a:r>
-              <a:rPr sz="1400" b="0">
-                <a:solidFill>
-                  <a:srgbClr val="101828"/>
-                </a:solidFill>
-                <a:latin typeface="Microsoft JhengHei"/>
-              </a:rPr>
-              <a:t>關稅戰擴大至加拿大</a:t>
-            </a:r>
-          </a:p>
-          <a:p>
-            <a:pPr algn="l">
-              <a:spcBef>
-                <a:spcPts val="0"/>
-              </a:spcBef>
-              <a:spcAft>
-                <a:spcPts val="200"/>
-              </a:spcAft>
-            </a:pPr>
-            <a:r>
-              <a:rPr sz="1400" b="0">
-                <a:solidFill>
-                  <a:srgbClr val="101828"/>
-                </a:solidFill>
-                <a:latin typeface="Microsoft JhengHei"/>
-              </a:rPr>
-              <a:t>通膨預期升溫</a:t>
+              <a:rPr sz="1250" b="0">
+                <a:solidFill>
+                  <a:srgbClr val="5B6472"/>
+                </a:solidFill>
+                <a:latin typeface="Microsoft JhengHei"/>
+              </a:rPr>
+              <a:t>與 6 月持平，通膨具黏滯性</a:t>
             </a:r>
           </a:p>
           <a:p>
@@ -5410,7 +5466,7 @@
                 </a:solidFill>
                 <a:latin typeface="Microsoft JhengHei"/>
               </a:rPr>
-              <a:t>伊朗與阿曼協商重啟霍爾木茲海峽臨時航道並排雷，全球通膨預期降溫。</a:t>
+              <a:t>伊朗與阿曼協商重啟霍爾木茲海峽航道；但通膨黏性未解，仍是升息的理由。</a:t>
             </a:r>
           </a:p>
           <a:p>
@@ -5429,7 +5485,7 @@
                 </a:solidFill>
                 <a:latin typeface="Microsoft JhengHei"/>
               </a:rPr>
-              <a:t>林漢偉、劉育綸、蔚辰</a:t>
+              <a:t>林漢偉、劉育綸、蔚辰、蔡明翰</a:t>
             </a:r>
           </a:p>
         </p:txBody>
@@ -5443,7 +5499,7 @@
         <p:spPr>
           <a:xfrm>
             <a:off x="8138160" y="1298448"/>
-            <a:ext cx="3675887" cy="2651760"/>
+            <a:ext cx="3675887" cy="2615184"/>
           </a:xfrm>
           <a:prstGeom prst="rect">
             <a:avLst/>
@@ -5530,7 +5586,7 @@
         </p:nvSpPr>
         <p:spPr>
           <a:xfrm>
-            <a:off x="8357616" y="1481328"/>
+            <a:off x="8357616" y="1463040"/>
             <a:ext cx="3236975" cy="2377440"/>
           </a:xfrm>
           <a:prstGeom prst="rect">
@@ -5549,7 +5605,7 @@
                 <a:spcPts val="0"/>
               </a:spcBef>
               <a:spcAft>
-                <a:spcPts val="800"/>
+                <a:spcPts val="700"/>
               </a:spcAft>
             </a:pPr>
             <a:r>
@@ -5568,36 +5624,17 @@
                 <a:spcPts val="0"/>
               </a:spcBef>
               <a:spcAft>
-                <a:spcPts val="300"/>
-              </a:spcAft>
-            </a:pPr>
-            <a:r>
-              <a:rPr sz="1050" b="0">
+                <a:spcPts val="200"/>
+              </a:spcAft>
+            </a:pPr>
+            <a:r>
+              <a:rPr sz="1250" b="0">
                 <a:solidFill>
                   <a:srgbClr val="5B6472"/>
                 </a:solidFill>
                 <a:latin typeface="Microsoft JhengHei"/>
               </a:rPr>
-              <a:t>週初</a:t>
-            </a:r>
-          </a:p>
-          <a:p>
-            <a:pPr algn="l">
-              <a:spcBef>
-                <a:spcPts val="0"/>
-              </a:spcBef>
-              <a:spcAft>
-                <a:spcPts val="200"/>
-              </a:spcAft>
-            </a:pPr>
-            <a:r>
-              <a:rPr sz="1400" b="0">
-                <a:solidFill>
-                  <a:srgbClr val="101828"/>
-                </a:solidFill>
-                <a:latin typeface="Microsoft JhengHei"/>
-              </a:rPr>
-              <a:t>外資大舉匯出 280 億美元</a:t>
+              <a:t>週初外資大舉匯出 280 億美元</a:t>
             </a:r>
           </a:p>
           <a:p>
@@ -5616,7 +5653,7 @@
                 </a:solidFill>
                 <a:latin typeface="Microsoft JhengHei"/>
               </a:rPr>
-              <a:t>↑　台幣升至 31.57</a:t>
+              <a:t>↑　台幣升至 31.57，8 月升幅近 2%</a:t>
             </a:r>
           </a:p>
           <a:p>
@@ -5635,7 +5672,7 @@
                 </a:solidFill>
                 <a:latin typeface="Microsoft JhengHei"/>
               </a:rPr>
-              <a:t>美元指數走弱，外資期現貨同步翻多，8 月買超 3,707 億元，創史上單月最高。</a:t>
+              <a:t>外資 8 月買超 3,707 億元創史上單月最高；但台幣急升同時衝擊出口商第三季利潤。</a:t>
             </a:r>
           </a:p>
           <a:p>
@@ -5654,7 +5691,7 @@
                 </a:solidFill>
                 <a:latin typeface="Microsoft JhengHei"/>
               </a:rPr>
-              <a:t>容逸燊、高憲容</a:t>
+              <a:t>容逸燊、高憲容、鍾國忠</a:t>
             </a:r>
           </a:p>
         </p:txBody>
@@ -5667,8 +5704,8 @@
         </p:nvSpPr>
         <p:spPr>
           <a:xfrm>
-            <a:off x="530352" y="4160520"/>
-            <a:ext cx="11130991" cy="1572768"/>
+            <a:off x="530352" y="4114800"/>
+            <a:ext cx="11130991" cy="1627632"/>
           </a:xfrm>
           <a:prstGeom prst="rect">
             <a:avLst/>
@@ -5711,8 +5748,8 @@
         </p:nvSpPr>
         <p:spPr>
           <a:xfrm>
-            <a:off x="530352" y="4160520"/>
-            <a:ext cx="38100" cy="1572768"/>
+            <a:off x="530352" y="4114800"/>
+            <a:ext cx="38100" cy="1627632"/>
           </a:xfrm>
           <a:prstGeom prst="rect">
             <a:avLst/>
@@ -5755,7 +5792,7 @@
         </p:nvSpPr>
         <p:spPr>
           <a:xfrm>
-            <a:off x="786384" y="4334256"/>
+            <a:off x="786384" y="4279392"/>
             <a:ext cx="10618927" cy="274320"/>
           </a:xfrm>
           <a:prstGeom prst="rect">
@@ -5784,7 +5821,7 @@
                 </a:solidFill>
                 <a:latin typeface="Microsoft JhengHei"/>
               </a:rPr>
-              <a:t>其他總經數字</a:t>
+              <a:t>週末補充：長天期美債與貶值交易</a:t>
             </a:r>
           </a:p>
         </p:txBody>
@@ -5797,8 +5834,8 @@
         </p:nvSpPr>
         <p:spPr>
           <a:xfrm>
-            <a:off x="786384" y="4754880"/>
-            <a:ext cx="3383280" cy="914400"/>
+            <a:off x="786384" y="4626864"/>
+            <a:ext cx="3383280" cy="1051560"/>
           </a:xfrm>
           <a:prstGeom prst="rect">
             <a:avLst/>
@@ -5820,13 +5857,13 @@
               </a:spcAft>
             </a:pPr>
             <a:r>
-              <a:rPr sz="1250" b="0">
+              <a:rPr sz="1200" b="0">
                 <a:solidFill>
                   <a:srgbClr val="101828"/>
                 </a:solidFill>
                 <a:latin typeface="Microsoft JhengHei"/>
               </a:rPr>
-              <a:t>7 月 PCE 年增 3.7%、核心 3.3%，與 6 月持平，通膨具黏滯性；9 月大機率按兵不動</a:t>
+              <a:t>30 年期美債殖利率突破 5.2%，期限溢價上升，反映市場擔心長債缺乏買家；科技巨頭為 AI 資本支出發債，7 月前已達 5,000 億美元，稀釋美債買盤</a:t>
             </a:r>
           </a:p>
           <a:p>
@@ -5845,7 +5882,7 @@
                 </a:solidFill>
                 <a:latin typeface="Microsoft JhengHei"/>
               </a:rPr>
-              <a:t>胡睿涵、祥維、紀緯明</a:t>
+              <a:t>M 平方 Viv</a:t>
             </a:r>
           </a:p>
         </p:txBody>
@@ -5858,8 +5895,8 @@
         </p:nvSpPr>
         <p:spPr>
           <a:xfrm>
-            <a:off x="4425696" y="4754880"/>
-            <a:ext cx="3383280" cy="914400"/>
+            <a:off x="4425696" y="4626864"/>
+            <a:ext cx="3383280" cy="1051560"/>
           </a:xfrm>
           <a:prstGeom prst="rect">
             <a:avLst/>
@@ -5881,13 +5918,13 @@
               </a:spcAft>
             </a:pPr>
             <a:r>
-              <a:rPr sz="1250" b="0">
+              <a:rPr sz="1200" b="0">
                 <a:solidFill>
                   <a:srgbClr val="101828"/>
                 </a:solidFill>
                 <a:latin typeface="Microsoft JhengHei"/>
               </a:rPr>
-              <a:t>台灣 7 月工業生產與製造業生產指數創單月歷史新高，景氣燈號連八紅</a:t>
+              <a:t>黃金一個月漲 15%、比特幣三天漲 20%，風險與避險資產同漲，反映的是對美元的「貶值交易」</a:t>
             </a:r>
           </a:p>
           <a:p>
@@ -5906,7 +5943,7 @@
                 </a:solidFill>
                 <a:latin typeface="Microsoft JhengHei"/>
               </a:rPr>
-              <a:t>蔚辰、游庭皓</a:t>
+              <a:t>M 平方 Viv</a:t>
             </a:r>
           </a:p>
         </p:txBody>
@@ -5919,8 +5956,8 @@
         </p:nvSpPr>
         <p:spPr>
           <a:xfrm>
-            <a:off x="8065008" y="4754880"/>
-            <a:ext cx="3383280" cy="914400"/>
+            <a:off x="8065008" y="4626864"/>
+            <a:ext cx="3383280" cy="1051560"/>
           </a:xfrm>
           <a:prstGeom prst="rect">
             <a:avLst/>
@@ -5942,13 +5979,13 @@
               </a:spcAft>
             </a:pPr>
             <a:r>
-              <a:rPr sz="1250" b="0">
+              <a:rPr sz="1200" b="0">
                 <a:solidFill>
                   <a:srgbClr val="101828"/>
                 </a:solidFill>
                 <a:latin typeface="Microsoft JhengHei"/>
               </a:rPr>
-              <a:t>大摩上修台灣今年經濟成長率至 11.6%，為 40 年來最快</a:t>
+              <a:t>台灣 7 月工業生產創單月歷史新高、景氣燈號連八紅；大摩上修今年經濟成長率至 11.6%，為 40 年來最快</a:t>
             </a:r>
           </a:p>
           <a:p>
@@ -5967,7 +6004,7 @@
                 </a:solidFill>
                 <a:latin typeface="Microsoft JhengHei"/>
               </a:rPr>
-              <a:t>胡睿涵</a:t>
+              <a:t>蔚辰、游庭皓、胡睿涵</a:t>
             </a:r>
           </a:p>
         </p:txBody>
@@ -6241,7 +6278,7 @@
                 </a:solidFill>
                 <a:latin typeface="Microsoft JhengHei"/>
               </a:rPr>
-              <a:t>以「五天當中有幾天被列為一致看多」計算</a:t>
+              <a:t>以「六份摘要中有幾份把它列進『一致看多』」計算</a:t>
             </a:r>
           </a:p>
         </p:txBody>
@@ -6306,7 +6343,7 @@
                           </a:solidFill>
                           <a:latin typeface="Microsoft JhengHei"/>
                         </a:rPr>
-                        <a:t>天數</a:t>
+                        <a:t>份數</a:t>
                       </a:r>
                     </a:p>
                   </a:txBody>
@@ -6448,7 +6485,7 @@
                           </a:solidFill>
                           <a:latin typeface="Consolas"/>
                         </a:rPr>
-                        <a:t>4</a:t>
+                        <a:t>3</a:t>
                       </a:r>
                     </a:p>
                   </a:txBody>
@@ -6471,7 +6508,7 @@
                           </a:solidFill>
                           <a:latin typeface="Microsoft JhengHei"/>
                         </a:rPr>
-                        <a:t>林漢偉、劉育綸、陳於晨、陳威良、囿羽</a:t>
+                        <a:t>林漢偉、劉育綸、陳於晨、陳威良</a:t>
                       </a:r>
                     </a:p>
                   </a:txBody>
@@ -6519,7 +6556,7 @@
                           </a:solidFill>
                           <a:latin typeface="Consolas"/>
                         </a:rPr>
-                        <a:t>4</a:t>
+                        <a:t>3</a:t>
                       </a:r>
                     </a:p>
                   </a:txBody>
@@ -6567,7 +6604,7 @@
                           </a:solidFill>
                           <a:latin typeface="Microsoft JhengHei"/>
                         </a:rPr>
-                        <a:t>先進封裝設備</a:t>
+                        <a:t>半導體展與先進封裝</a:t>
                       </a:r>
                     </a:p>
                   </a:txBody>
@@ -6590,7 +6627,7 @@
                           </a:solidFill>
                           <a:latin typeface="Consolas"/>
                         </a:rPr>
-                        <a:t>2</a:t>
+                        <a:t>1</a:t>
                       </a:r>
                     </a:p>
                   </a:txBody>
@@ -6613,7 +6650,7 @@
                           </a:solidFill>
                           <a:latin typeface="Microsoft JhengHei"/>
                         </a:rPr>
-                        <a:t>容逸燊、陳昆仁、祥維、囿羽</a:t>
+                        <a:t>林漢偉、鍾國忠（週末新增，09/02 開展）</a:t>
                       </a:r>
                     </a:p>
                   </a:txBody>
@@ -6823,7 +6860,7 @@
         <p:spPr>
           <a:xfrm>
             <a:off x="3319272" y="2112264"/>
-            <a:ext cx="877824" cy="101600"/>
+            <a:ext cx="658368" cy="101600"/>
           </a:xfrm>
           <a:prstGeom prst="rect">
             <a:avLst/>
@@ -6867,7 +6904,7 @@
         <p:spPr>
           <a:xfrm>
             <a:off x="3319272" y="2496312"/>
-            <a:ext cx="877824" cy="101600"/>
+            <a:ext cx="658368" cy="101600"/>
           </a:xfrm>
           <a:prstGeom prst="rect">
             <a:avLst/>
@@ -6911,7 +6948,7 @@
         <p:spPr>
           <a:xfrm>
             <a:off x="3319272" y="2880360"/>
-            <a:ext cx="438912" cy="101600"/>
+            <a:ext cx="219456" cy="101600"/>
           </a:xfrm>
           <a:prstGeom prst="rect">
             <a:avLst/>
@@ -7115,7 +7152,7 @@
                 </a:solidFill>
                 <a:latin typeface="Microsoft JhengHei"/>
               </a:rPr>
-              <a:t>跨日重複出現的個股（括號為週內被列入一致看多的天數）</a:t>
+              <a:t>跨日重複出現的個股（數字為被列入一致看多的份數，共 6 份）</a:t>
             </a:r>
           </a:p>
         </p:txBody>
@@ -7242,7 +7279,7 @@
           </a:solidFill>
           <a:ln w="9525">
             <a:solidFill>
-              <a:srgbClr val="E9B7BB"/>
+              <a:srgbClr val="C1121F"/>
             </a:solidFill>
           </a:ln>
           <a:effectLst/>
@@ -7303,7 +7340,7 @@
                 </a:solidFill>
                 <a:latin typeface="Microsoft JhengHei"/>
               </a:rPr>
-              <a:t>聯亞　</a:t>
+              <a:t>南亞科　</a:t>
             </a:r>
             <a:r>
               <a:rPr sz="1050" b="0">
@@ -7312,7 +7349,7 @@
                 </a:solidFill>
                 <a:latin typeface="Consolas"/>
               </a:rPr>
-              <a:t>3081　</a:t>
+              <a:t>2408　</a:t>
             </a:r>
             <a:r>
               <a:rPr sz="1300" b="1">
@@ -7321,7 +7358,7 @@
                 </a:solidFill>
                 <a:latin typeface="Consolas"/>
               </a:rPr>
-              <a:t>3</a:t>
+              <a:t>4</a:t>
             </a:r>
           </a:p>
         </p:txBody>
@@ -7406,7 +7443,7 @@
                 </a:solidFill>
                 <a:latin typeface="Microsoft JhengHei"/>
               </a:rPr>
-              <a:t>南亞科　</a:t>
+              <a:t>聯亞　</a:t>
             </a:r>
             <a:r>
               <a:rPr sz="1050" b="0">
@@ -7415,7 +7452,7 @@
                 </a:solidFill>
                 <a:latin typeface="Consolas"/>
               </a:rPr>
-              <a:t>2408　</a:t>
+              <a:t>3081　</a:t>
             </a:r>
             <a:r>
               <a:rPr sz="1300" b="1">
@@ -7438,6 +7475,212 @@
         <p:spPr>
           <a:xfrm>
             <a:off x="7424928" y="4800600"/>
+            <a:ext cx="2048256" cy="384048"/>
+          </a:xfrm>
+          <a:prstGeom prst="rect">
+            <a:avLst/>
+          </a:prstGeom>
+          <a:solidFill>
+            <a:srgbClr val="FFFFFF"/>
+          </a:solidFill>
+          <a:ln w="9525">
+            <a:solidFill>
+              <a:srgbClr val="E9B7BB"/>
+            </a:solidFill>
+          </a:ln>
+          <a:effectLst/>
+        </p:spPr>
+        <p:style>
+          <a:lnRef idx="1">
+            <a:schemeClr val="accent1"/>
+          </a:lnRef>
+          <a:fillRef idx="3">
+            <a:schemeClr val="accent1"/>
+          </a:fillRef>
+          <a:effectRef idx="2">
+            <a:schemeClr val="accent1"/>
+          </a:effectRef>
+          <a:fontRef idx="minor">
+            <a:schemeClr val="lt1"/>
+          </a:fontRef>
+        </p:style>
+        <p:txBody>
+          <a:bodyPr rtlCol="0" anchor="ctr"/>
+          <a:lstStyle/>
+          <a:p>
+            <a:pPr algn="ctr"/>
+          </a:p>
+        </p:txBody>
+      </p:sp>
+      <p:sp>
+        <p:nvSpPr>
+          <p:cNvPr id="23" name="TextBox 22"/>
+          <p:cNvSpPr txBox="1"/>
+          <p:nvPr/>
+        </p:nvSpPr>
+        <p:spPr>
+          <a:xfrm>
+            <a:off x="7534656" y="4873752"/>
+            <a:ext cx="1828800" cy="274320"/>
+          </a:xfrm>
+          <a:prstGeom prst="rect">
+            <a:avLst/>
+          </a:prstGeom>
+          <a:noFill/>
+        </p:spPr>
+        <p:txBody>
+          <a:bodyPr wrap="square" anchor="t" lIns="0" rIns="0" tIns="0" bIns="0">
+            <a:spAutoFit/>
+          </a:bodyPr>
+          <a:lstStyle/>
+          <a:p>
+            <a:pPr>
+              <a:spcAft>
+                <a:spcPts val="0"/>
+              </a:spcAft>
+            </a:pPr>
+            <a:r>
+              <a:rPr sz="1300" b="1">
+                <a:solidFill>
+                  <a:srgbClr val="101828"/>
+                </a:solidFill>
+                <a:latin typeface="Microsoft JhengHei"/>
+              </a:rPr>
+              <a:t>台積電　</a:t>
+            </a:r>
+            <a:r>
+              <a:rPr sz="1050" b="0">
+                <a:solidFill>
+                  <a:srgbClr val="5B6472"/>
+                </a:solidFill>
+                <a:latin typeface="Consolas"/>
+              </a:rPr>
+              <a:t>2330　</a:t>
+            </a:r>
+            <a:r>
+              <a:rPr sz="1300" b="1">
+                <a:solidFill>
+                  <a:srgbClr val="C1121F"/>
+                </a:solidFill>
+                <a:latin typeface="Consolas"/>
+              </a:rPr>
+              <a:t>3</a:t>
+            </a:r>
+          </a:p>
+        </p:txBody>
+      </p:sp>
+      <p:sp>
+        <p:nvSpPr>
+          <p:cNvPr id="24" name="Rectangle 23"/>
+          <p:cNvSpPr/>
+          <p:nvPr/>
+        </p:nvSpPr>
+        <p:spPr>
+          <a:xfrm>
+            <a:off x="9637776" y="4800600"/>
+            <a:ext cx="2048256" cy="384048"/>
+          </a:xfrm>
+          <a:prstGeom prst="rect">
+            <a:avLst/>
+          </a:prstGeom>
+          <a:solidFill>
+            <a:srgbClr val="FFFFFF"/>
+          </a:solidFill>
+          <a:ln w="9525">
+            <a:solidFill>
+              <a:srgbClr val="E9B7BB"/>
+            </a:solidFill>
+          </a:ln>
+          <a:effectLst/>
+        </p:spPr>
+        <p:style>
+          <a:lnRef idx="1">
+            <a:schemeClr val="accent1"/>
+          </a:lnRef>
+          <a:fillRef idx="3">
+            <a:schemeClr val="accent1"/>
+          </a:fillRef>
+          <a:effectRef idx="2">
+            <a:schemeClr val="accent1"/>
+          </a:effectRef>
+          <a:fontRef idx="minor">
+            <a:schemeClr val="lt1"/>
+          </a:fontRef>
+        </p:style>
+        <p:txBody>
+          <a:bodyPr rtlCol="0" anchor="ctr"/>
+          <a:lstStyle/>
+          <a:p>
+            <a:pPr algn="ctr"/>
+          </a:p>
+        </p:txBody>
+      </p:sp>
+      <p:sp>
+        <p:nvSpPr>
+          <p:cNvPr id="25" name="TextBox 24"/>
+          <p:cNvSpPr txBox="1"/>
+          <p:nvPr/>
+        </p:nvSpPr>
+        <p:spPr>
+          <a:xfrm>
+            <a:off x="9747504" y="4873752"/>
+            <a:ext cx="1828800" cy="274320"/>
+          </a:xfrm>
+          <a:prstGeom prst="rect">
+            <a:avLst/>
+          </a:prstGeom>
+          <a:noFill/>
+        </p:spPr>
+        <p:txBody>
+          <a:bodyPr wrap="square" anchor="t" lIns="0" rIns="0" tIns="0" bIns="0">
+            <a:spAutoFit/>
+          </a:bodyPr>
+          <a:lstStyle/>
+          <a:p>
+            <a:pPr>
+              <a:spcAft>
+                <a:spcPts val="0"/>
+              </a:spcAft>
+            </a:pPr>
+            <a:r>
+              <a:rPr sz="1300" b="1">
+                <a:solidFill>
+                  <a:srgbClr val="101828"/>
+                </a:solidFill>
+                <a:latin typeface="Microsoft JhengHei"/>
+              </a:rPr>
+              <a:t>聯電　</a:t>
+            </a:r>
+            <a:r>
+              <a:rPr sz="1050" b="0">
+                <a:solidFill>
+                  <a:srgbClr val="5B6472"/>
+                </a:solidFill>
+                <a:latin typeface="Consolas"/>
+              </a:rPr>
+              <a:t>2303　</a:t>
+            </a:r>
+            <a:r>
+              <a:rPr sz="1300" b="1">
+                <a:solidFill>
+                  <a:srgbClr val="C1121F"/>
+                </a:solidFill>
+                <a:latin typeface="Consolas"/>
+              </a:rPr>
+              <a:t>3</a:t>
+            </a:r>
+          </a:p>
+        </p:txBody>
+      </p:sp>
+      <p:sp>
+        <p:nvSpPr>
+          <p:cNvPr id="26" name="Rectangle 25"/>
+          <p:cNvSpPr/>
+          <p:nvPr/>
+        </p:nvSpPr>
+        <p:spPr>
+          <a:xfrm>
+            <a:off x="786384" y="5276088"/>
             <a:ext cx="2048256" cy="384048"/>
           </a:xfrm>
           <a:prstGeom prst="rect">
@@ -7477,13 +7720,13 @@
       </p:sp>
       <p:sp>
         <p:nvSpPr>
-          <p:cNvPr id="23" name="TextBox 22"/>
+          <p:cNvPr id="27" name="TextBox 26"/>
           <p:cNvSpPr txBox="1"/>
           <p:nvPr/>
         </p:nvSpPr>
         <p:spPr>
           <a:xfrm>
-            <a:off x="7534656" y="4873752"/>
+            <a:off x="896112" y="5349240"/>
             <a:ext cx="1828800" cy="274320"/>
           </a:xfrm>
           <a:prstGeom prst="rect">
@@ -7534,13 +7777,13 @@
       </p:sp>
       <p:sp>
         <p:nvSpPr>
-          <p:cNvPr id="24" name="Rectangle 23"/>
+          <p:cNvPr id="28" name="Rectangle 27"/>
           <p:cNvSpPr/>
           <p:nvPr/>
         </p:nvSpPr>
         <p:spPr>
           <a:xfrm>
-            <a:off x="9637776" y="4800600"/>
+            <a:off x="2999232" y="5276088"/>
             <a:ext cx="2048256" cy="384048"/>
           </a:xfrm>
           <a:prstGeom prst="rect">
@@ -7580,13 +7823,13 @@
       </p:sp>
       <p:sp>
         <p:nvSpPr>
-          <p:cNvPr id="25" name="TextBox 24"/>
+          <p:cNvPr id="29" name="TextBox 28"/>
           <p:cNvSpPr txBox="1"/>
           <p:nvPr/>
         </p:nvSpPr>
         <p:spPr>
           <a:xfrm>
-            <a:off x="9747504" y="4873752"/>
+            <a:off x="3108960" y="5349240"/>
             <a:ext cx="1828800" cy="274320"/>
           </a:xfrm>
           <a:prstGeom prst="rect">
@@ -7637,13 +7880,13 @@
       </p:sp>
       <p:sp>
         <p:nvSpPr>
-          <p:cNvPr id="26" name="Rectangle 25"/>
+          <p:cNvPr id="30" name="Rectangle 29"/>
           <p:cNvSpPr/>
           <p:nvPr/>
         </p:nvSpPr>
         <p:spPr>
           <a:xfrm>
-            <a:off x="786384" y="5276088"/>
+            <a:off x="5212080" y="5276088"/>
             <a:ext cx="2048256" cy="384048"/>
           </a:xfrm>
           <a:prstGeom prst="rect">
@@ -7683,13 +7926,13 @@
       </p:sp>
       <p:sp>
         <p:nvSpPr>
-          <p:cNvPr id="27" name="TextBox 26"/>
+          <p:cNvPr id="31" name="TextBox 30"/>
           <p:cNvSpPr txBox="1"/>
           <p:nvPr/>
         </p:nvSpPr>
         <p:spPr>
           <a:xfrm>
-            <a:off x="896112" y="5349240"/>
+            <a:off x="5321808" y="5349240"/>
             <a:ext cx="1828800" cy="274320"/>
           </a:xfrm>
           <a:prstGeom prst="rect">
@@ -7715,7 +7958,7 @@
                 </a:solidFill>
                 <a:latin typeface="Microsoft JhengHei"/>
               </a:rPr>
-              <a:t>聯茂　</a:t>
+              <a:t>華邦電　</a:t>
             </a:r>
             <a:r>
               <a:rPr sz="1050" b="0">
@@ -7724,7 +7967,7 @@
                 </a:solidFill>
                 <a:latin typeface="Consolas"/>
               </a:rPr>
-              <a:t>6213　</a:t>
+              <a:t>2344　</a:t>
             </a:r>
             <a:r>
               <a:rPr sz="1300" b="1">
@@ -7740,13 +7983,13 @@
       </p:sp>
       <p:sp>
         <p:nvSpPr>
-          <p:cNvPr id="28" name="Rectangle 27"/>
+          <p:cNvPr id="32" name="Rectangle 31"/>
           <p:cNvSpPr/>
           <p:nvPr/>
         </p:nvSpPr>
         <p:spPr>
           <a:xfrm>
-            <a:off x="2999232" y="5276088"/>
+            <a:off x="7424928" y="5276088"/>
             <a:ext cx="2048256" cy="384048"/>
           </a:xfrm>
           <a:prstGeom prst="rect">
@@ -7786,13 +8029,13 @@
       </p:sp>
       <p:sp>
         <p:nvSpPr>
-          <p:cNvPr id="29" name="TextBox 28"/>
+          <p:cNvPr id="33" name="TextBox 32"/>
           <p:cNvSpPr txBox="1"/>
           <p:nvPr/>
         </p:nvSpPr>
         <p:spPr>
           <a:xfrm>
-            <a:off x="3108960" y="5349240"/>
+            <a:off x="7534656" y="5349240"/>
             <a:ext cx="1828800" cy="274320"/>
           </a:xfrm>
           <a:prstGeom prst="rect">
@@ -7818,7 +8061,7 @@
                 </a:solidFill>
                 <a:latin typeface="Microsoft JhengHei"/>
               </a:rPr>
-              <a:t>聯電　</a:t>
+              <a:t>光寶科　</a:t>
             </a:r>
             <a:r>
               <a:rPr sz="1050" b="0">
@@ -7827,7 +8070,7 @@
                 </a:solidFill>
                 <a:latin typeface="Consolas"/>
               </a:rPr>
-              <a:t>2303　</a:t>
+              <a:t>2301　</a:t>
             </a:r>
             <a:r>
               <a:rPr sz="1300" b="1">
@@ -7843,13 +8086,13 @@
       </p:sp>
       <p:sp>
         <p:nvSpPr>
-          <p:cNvPr id="30" name="Rectangle 29"/>
+          <p:cNvPr id="34" name="Rectangle 33"/>
           <p:cNvSpPr/>
           <p:nvPr/>
         </p:nvSpPr>
         <p:spPr>
           <a:xfrm>
-            <a:off x="5212080" y="5276088"/>
+            <a:off x="9637776" y="5276088"/>
             <a:ext cx="2048256" cy="384048"/>
           </a:xfrm>
           <a:prstGeom prst="rect">
@@ -7889,13 +8132,13 @@
       </p:sp>
       <p:sp>
         <p:nvSpPr>
-          <p:cNvPr id="31" name="TextBox 30"/>
+          <p:cNvPr id="35" name="TextBox 34"/>
           <p:cNvSpPr txBox="1"/>
           <p:nvPr/>
         </p:nvSpPr>
         <p:spPr>
           <a:xfrm>
-            <a:off x="5321808" y="5349240"/>
+            <a:off x="9747504" y="5349240"/>
             <a:ext cx="1828800" cy="274320"/>
           </a:xfrm>
           <a:prstGeom prst="rect">
@@ -7921,7 +8164,7 @@
                 </a:solidFill>
                 <a:latin typeface="Microsoft JhengHei"/>
               </a:rPr>
-              <a:t>光寶科　</a:t>
+              <a:t>創意　</a:t>
             </a:r>
             <a:r>
               <a:rPr sz="1050" b="0">
@@ -7930,7 +8173,7 @@
                 </a:solidFill>
                 <a:latin typeface="Consolas"/>
               </a:rPr>
-              <a:t>2301　</a:t>
+              <a:t>3443　</a:t>
             </a:r>
             <a:r>
               <a:rPr sz="1300" b="1">
@@ -7939,67 +8182,21 @@
                 </a:solidFill>
                 <a:latin typeface="Consolas"/>
               </a:rPr>
-              <a:t>2</a:t>
-            </a:r>
-          </a:p>
-        </p:txBody>
-      </p:sp>
-      <p:sp>
-        <p:nvSpPr>
-          <p:cNvPr id="32" name="Rectangle 31"/>
-          <p:cNvSpPr/>
-          <p:nvPr/>
-        </p:nvSpPr>
-        <p:spPr>
-          <a:xfrm>
-            <a:off x="7424928" y="5276088"/>
-            <a:ext cx="2048256" cy="384048"/>
-          </a:xfrm>
-          <a:prstGeom prst="rect">
-            <a:avLst/>
-          </a:prstGeom>
-          <a:solidFill>
-            <a:srgbClr val="FFFFFF"/>
-          </a:solidFill>
-          <a:ln w="9525">
-            <a:solidFill>
-              <a:srgbClr val="D8DEE7"/>
-            </a:solidFill>
-          </a:ln>
-          <a:effectLst/>
-        </p:spPr>
-        <p:style>
-          <a:lnRef idx="1">
-            <a:schemeClr val="accent1"/>
-          </a:lnRef>
-          <a:fillRef idx="3">
-            <a:schemeClr val="accent1"/>
-          </a:fillRef>
-          <a:effectRef idx="2">
-            <a:schemeClr val="accent1"/>
-          </a:effectRef>
-          <a:fontRef idx="minor">
-            <a:schemeClr val="lt1"/>
-          </a:fontRef>
-        </p:style>
-        <p:txBody>
-          <a:bodyPr rtlCol="0" anchor="ctr"/>
-          <a:lstStyle/>
-          <a:p>
-            <a:pPr algn="ctr"/>
-          </a:p>
-        </p:txBody>
-      </p:sp>
-      <p:sp>
-        <p:nvSpPr>
-          <p:cNvPr id="33" name="TextBox 32"/>
+              <a:t>1</a:t>
+            </a:r>
+          </a:p>
+        </p:txBody>
+      </p:sp>
+      <p:sp>
+        <p:nvSpPr>
+          <p:cNvPr id="36" name="TextBox 35"/>
           <p:cNvSpPr txBox="1"/>
           <p:nvPr/>
         </p:nvSpPr>
         <p:spPr>
           <a:xfrm>
-            <a:off x="7534656" y="5349240"/>
-            <a:ext cx="1828800" cy="274320"/>
+            <a:off x="530352" y="6382512"/>
+            <a:ext cx="11130991" cy="292608"/>
           </a:xfrm>
           <a:prstGeom prst="rect">
             <a:avLst/>
@@ -8012,166 +8209,6 @@
           </a:bodyPr>
           <a:lstStyle/>
           <a:p>
-            <a:pPr>
-              <a:spcAft>
-                <a:spcPts val="0"/>
-              </a:spcAft>
-            </a:pPr>
-            <a:r>
-              <a:rPr sz="1300" b="0">
-                <a:solidFill>
-                  <a:srgbClr val="101828"/>
-                </a:solidFill>
-                <a:latin typeface="Microsoft JhengHei"/>
-              </a:rPr>
-              <a:t>環球晶　</a:t>
-            </a:r>
-            <a:r>
-              <a:rPr sz="1050" b="0">
-                <a:solidFill>
-                  <a:srgbClr val="5B6472"/>
-                </a:solidFill>
-                <a:latin typeface="Consolas"/>
-              </a:rPr>
-              <a:t>6488　</a:t>
-            </a:r>
-            <a:r>
-              <a:rPr sz="1300" b="1">
-                <a:solidFill>
-                  <a:srgbClr val="5B6472"/>
-                </a:solidFill>
-                <a:latin typeface="Consolas"/>
-              </a:rPr>
-              <a:t>2</a:t>
-            </a:r>
-          </a:p>
-        </p:txBody>
-      </p:sp>
-      <p:sp>
-        <p:nvSpPr>
-          <p:cNvPr id="34" name="Rectangle 33"/>
-          <p:cNvSpPr/>
-          <p:nvPr/>
-        </p:nvSpPr>
-        <p:spPr>
-          <a:xfrm>
-            <a:off x="9637776" y="5276088"/>
-            <a:ext cx="2048256" cy="384048"/>
-          </a:xfrm>
-          <a:prstGeom prst="rect">
-            <a:avLst/>
-          </a:prstGeom>
-          <a:solidFill>
-            <a:srgbClr val="FFFFFF"/>
-          </a:solidFill>
-          <a:ln w="9525">
-            <a:solidFill>
-              <a:srgbClr val="D8DEE7"/>
-            </a:solidFill>
-          </a:ln>
-          <a:effectLst/>
-        </p:spPr>
-        <p:style>
-          <a:lnRef idx="1">
-            <a:schemeClr val="accent1"/>
-          </a:lnRef>
-          <a:fillRef idx="3">
-            <a:schemeClr val="accent1"/>
-          </a:fillRef>
-          <a:effectRef idx="2">
-            <a:schemeClr val="accent1"/>
-          </a:effectRef>
-          <a:fontRef idx="minor">
-            <a:schemeClr val="lt1"/>
-          </a:fontRef>
-        </p:style>
-        <p:txBody>
-          <a:bodyPr rtlCol="0" anchor="ctr"/>
-          <a:lstStyle/>
-          <a:p>
-            <a:pPr algn="ctr"/>
-          </a:p>
-        </p:txBody>
-      </p:sp>
-      <p:sp>
-        <p:nvSpPr>
-          <p:cNvPr id="35" name="TextBox 34"/>
-          <p:cNvSpPr txBox="1"/>
-          <p:nvPr/>
-        </p:nvSpPr>
-        <p:spPr>
-          <a:xfrm>
-            <a:off x="9747504" y="5349240"/>
-            <a:ext cx="1828800" cy="274320"/>
-          </a:xfrm>
-          <a:prstGeom prst="rect">
-            <a:avLst/>
-          </a:prstGeom>
-          <a:noFill/>
-        </p:spPr>
-        <p:txBody>
-          <a:bodyPr wrap="square" anchor="t" lIns="0" rIns="0" tIns="0" bIns="0">
-            <a:spAutoFit/>
-          </a:bodyPr>
-          <a:lstStyle/>
-          <a:p>
-            <a:pPr>
-              <a:spcAft>
-                <a:spcPts val="0"/>
-              </a:spcAft>
-            </a:pPr>
-            <a:r>
-              <a:rPr sz="1300" b="0">
-                <a:solidFill>
-                  <a:srgbClr val="101828"/>
-                </a:solidFill>
-                <a:latin typeface="Microsoft JhengHei"/>
-              </a:rPr>
-              <a:t>華星光　</a:t>
-            </a:r>
-            <a:r>
-              <a:rPr sz="1050" b="0">
-                <a:solidFill>
-                  <a:srgbClr val="5B6472"/>
-                </a:solidFill>
-                <a:latin typeface="Consolas"/>
-              </a:rPr>
-              <a:t>4979　</a:t>
-            </a:r>
-            <a:r>
-              <a:rPr sz="1300" b="1">
-                <a:solidFill>
-                  <a:srgbClr val="5B6472"/>
-                </a:solidFill>
-                <a:latin typeface="Consolas"/>
-              </a:rPr>
-              <a:t>2</a:t>
-            </a:r>
-          </a:p>
-        </p:txBody>
-      </p:sp>
-      <p:sp>
-        <p:nvSpPr>
-          <p:cNvPr id="36" name="TextBox 35"/>
-          <p:cNvSpPr txBox="1"/>
-          <p:nvPr/>
-        </p:nvSpPr>
-        <p:spPr>
-          <a:xfrm>
-            <a:off x="530352" y="6382512"/>
-            <a:ext cx="11130991" cy="292608"/>
-          </a:xfrm>
-          <a:prstGeom prst="rect">
-            <a:avLst/>
-          </a:prstGeom>
-          <a:noFill/>
-        </p:spPr>
-        <p:txBody>
-          <a:bodyPr wrap="square" anchor="t" lIns="0" rIns="0" tIns="0" bIns="0">
-            <a:spAutoFit/>
-          </a:bodyPr>
-          <a:lstStyle/>
-          <a:p>
             <a:pPr algn="l">
               <a:spcBef>
                 <a:spcPts val="0"/>
@@ -8187,7 +8224,7 @@
                 </a:solidFill>
                 <a:latin typeface="Microsoft JhengHei"/>
               </a:rPr>
-              <a:t>天數為五個交易日內被列入「一致看多」章節的次數，非漲跌統計。</a:t>
+              <a:t>份數為六份摘要中被列入「一致看多」章節的次數，非漲跌統計；個別分析師單獨看好不計入。</a:t>
             </a:r>
           </a:p>
         </p:txBody>
@@ -8519,7 +8556,7 @@
         <p:spPr>
           <a:xfrm>
             <a:off x="530352" y="1783080"/>
-            <a:ext cx="5577840" cy="1078992"/>
+            <a:ext cx="5577840" cy="1005840"/>
           </a:xfrm>
           <a:prstGeom prst="rect">
             <a:avLst/>
@@ -8563,7 +8600,7 @@
         <p:spPr>
           <a:xfrm>
             <a:off x="530352" y="1783080"/>
-            <a:ext cx="38100" cy="1078992"/>
+            <a:ext cx="38100" cy="1005840"/>
           </a:xfrm>
           <a:prstGeom prst="rect">
             <a:avLst/>
@@ -8649,7 +8686,7 @@
         <p:spPr>
           <a:xfrm>
             <a:off x="1810512" y="1911096"/>
-            <a:ext cx="4114800" cy="822960"/>
+            <a:ext cx="4114800" cy="749808"/>
           </a:xfrm>
           <a:prstGeom prst="rect">
             <a:avLst/>
@@ -8683,7 +8720,7 @@
                 </a:solidFill>
                 <a:latin typeface="Microsoft JhengHei"/>
               </a:rPr>
-              <a:t>林漢偉、張林忠、老王 —— 塞港短期無解、低本益比高殖利率</a:t>
+              <a:t>林漢偉、張林忠、老王：塞港短期無解、低本益比高殖利率</a:t>
             </a:r>
           </a:p>
           <a:p>
@@ -8715,8 +8752,8 @@
         </p:nvSpPr>
         <p:spPr>
           <a:xfrm>
-            <a:off x="530352" y="2971800"/>
-            <a:ext cx="5577840" cy="1078992"/>
+            <a:off x="530352" y="2898648"/>
+            <a:ext cx="5577840" cy="1188720"/>
           </a:xfrm>
           <a:prstGeom prst="rect">
             <a:avLst/>
@@ -8759,8 +8796,8 @@
         </p:nvSpPr>
         <p:spPr>
           <a:xfrm>
-            <a:off x="530352" y="2971800"/>
-            <a:ext cx="38100" cy="1078992"/>
+            <a:off x="530352" y="2898648"/>
+            <a:ext cx="38100" cy="1188720"/>
           </a:xfrm>
           <a:prstGeom prst="rect">
             <a:avLst/>
@@ -8803,7 +8840,7 @@
         </p:nvSpPr>
         <p:spPr>
           <a:xfrm>
-            <a:off x="749808" y="3118104"/>
+            <a:off x="749808" y="3044952"/>
             <a:ext cx="1005840" cy="274320"/>
           </a:xfrm>
           <a:prstGeom prst="rect">
@@ -8845,8 +8882,8 @@
         </p:nvSpPr>
         <p:spPr>
           <a:xfrm>
-            <a:off x="1810512" y="3099816"/>
-            <a:ext cx="4114800" cy="822960"/>
+            <a:off x="1810512" y="3026664"/>
+            <a:ext cx="4114800" cy="932688"/>
           </a:xfrm>
           <a:prstGeom prst="rect">
             <a:avLst/>
@@ -8912,8 +8949,8 @@
         </p:nvSpPr>
         <p:spPr>
           <a:xfrm>
-            <a:off x="530352" y="4160520"/>
-            <a:ext cx="5577840" cy="786384"/>
+            <a:off x="530352" y="4197096"/>
+            <a:ext cx="5577840" cy="1188720"/>
           </a:xfrm>
           <a:prstGeom prst="rect">
             <a:avLst/>
@@ -8956,14 +8993,14 @@
         </p:nvSpPr>
         <p:spPr>
           <a:xfrm>
-            <a:off x="530352" y="4160520"/>
-            <a:ext cx="38100" cy="786384"/>
+            <a:off x="530352" y="4197096"/>
+            <a:ext cx="38100" cy="1188720"/>
           </a:xfrm>
           <a:prstGeom prst="rect">
             <a:avLst/>
           </a:prstGeom>
           <a:solidFill>
-            <a:srgbClr val="5B6472"/>
+            <a:srgbClr val="0F7A55"/>
           </a:solidFill>
           <a:ln>
             <a:noFill/>
@@ -9000,7 +9037,7 @@
         </p:nvSpPr>
         <p:spPr>
           <a:xfrm>
-            <a:off x="749808" y="4306824"/>
+            <a:off x="749808" y="4343400"/>
             <a:ext cx="1005840" cy="274320"/>
           </a:xfrm>
           <a:prstGeom prst="rect">
@@ -9025,11 +9062,11 @@
             <a:r>
               <a:rPr sz="1300" b="1">
                 <a:solidFill>
-                  <a:srgbClr val="5B6472"/>
+                  <a:srgbClr val="0F7A55"/>
                 </a:solidFill>
                 <a:latin typeface="Consolas"/>
               </a:rPr>
-              <a:t>08/27</a:t>
+              <a:t>08/28</a:t>
             </a:r>
           </a:p>
         </p:txBody>
@@ -9042,8 +9079,8 @@
         </p:nvSpPr>
         <p:spPr>
           <a:xfrm>
-            <a:off x="1810512" y="4288536"/>
-            <a:ext cx="4114800" cy="530352"/>
+            <a:off x="1810512" y="4325112"/>
+            <a:ext cx="4114800" cy="932688"/>
           </a:xfrm>
           <a:prstGeom prst="rect">
             <a:avLst/>
@@ -9064,20 +9101,39 @@
             <a:r>
               <a:rPr sz="1300" b="1">
                 <a:solidFill>
+                  <a:srgbClr val="0F7A55"/>
+                </a:solidFill>
+                <a:latin typeface="Microsoft JhengHei"/>
+              </a:rPr>
+              <a:t>確認　</a:t>
+            </a:r>
+            <a:r>
+              <a:rPr sz="1250">
+                <a:solidFill>
+                  <a:srgbClr val="101828"/>
+                </a:solidFill>
+                <a:latin typeface="Microsoft JhengHei"/>
+              </a:rPr>
+              <a:t>老王：成交量從 20 萬張乾涸到 4.5 萬張，融券連四天大回補，陽明、萬海、長榮三檔全數看空、信心高</a:t>
+            </a:r>
+          </a:p>
+          <a:p>
+            <a:pPr algn="l">
+              <a:spcBef>
+                <a:spcPts val="0"/>
+              </a:spcBef>
+              <a:spcAft>
+                <a:spcPts val="0"/>
+              </a:spcAft>
+            </a:pPr>
+            <a:r>
+              <a:rPr sz="1150" b="0">
+                <a:solidFill>
                   <a:srgbClr val="5B6472"/>
                 </a:solidFill>
                 <a:latin typeface="Microsoft JhengHei"/>
               </a:rPr>
-              <a:t>中性　</a:t>
-            </a:r>
-            <a:r>
-              <a:rPr sz="1250">
-                <a:solidFill>
-                  <a:srgbClr val="101828"/>
-                </a:solidFill>
-                <a:latin typeface="Microsoft JhengHei"/>
-              </a:rPr>
-              <a:t>陳昆仁僅視為非 AI 的強勢概念股，低進高出</a:t>
+              <a:t>「空頭投降、高點即現，多頭漲勢正式宣告結束」</a:t>
             </a:r>
           </a:p>
         </p:txBody>
@@ -9090,7 +9146,7 @@
         </p:nvSpPr>
         <p:spPr>
           <a:xfrm>
-            <a:off x="530352" y="5029200"/>
+            <a:off x="530352" y="5486400"/>
             <a:ext cx="5577840" cy="548640"/>
           </a:xfrm>
           <a:prstGeom prst="rect">
@@ -9119,7 +9175,7 @@
                 </a:solidFill>
                 <a:latin typeface="Microsoft JhengHei"/>
               </a:rPr>
-              <a:t>同一族群、同一位分析師，兩天內方向相反 —— 這是逐日摘要才看得出來的東西。</a:t>
+              <a:t>同一族群、同一位分析師，兩天內方向相反，這是逐日摘要才看得出來的東西。</a:t>
             </a:r>
           </a:p>
         </p:txBody>
@@ -9205,7 +9261,7 @@
                 </a:solidFill>
                 <a:latin typeface="Microsoft JhengHei"/>
               </a:rPr>
-              <a:t>欣興（3037）：週五爆出的個股事件</a:t>
+              <a:t>欣興（3037）：週五爆出、週末才釐清</a:t>
             </a:r>
           </a:p>
         </p:txBody>
@@ -9219,7 +9275,7 @@
         <p:spPr>
           <a:xfrm>
             <a:off x="6492240" y="1783080"/>
-            <a:ext cx="5169103" cy="1874519"/>
+            <a:ext cx="5169103" cy="2240280"/>
           </a:xfrm>
           <a:prstGeom prst="rect">
             <a:avLst/>
@@ -9262,8 +9318,8 @@
         </p:nvSpPr>
         <p:spPr>
           <a:xfrm>
-            <a:off x="6711696" y="1956816"/>
-            <a:ext cx="4730191" cy="1554480"/>
+            <a:off x="6711696" y="1938528"/>
+            <a:ext cx="4730191" cy="2011680"/>
           </a:xfrm>
           <a:prstGeom prst="rect">
             <a:avLst/>
@@ -9281,17 +9337,17 @@
                 <a:spcPts val="0"/>
               </a:spcBef>
               <a:spcAft>
-                <a:spcPts val="700"/>
-              </a:spcAft>
-            </a:pPr>
-            <a:r>
-              <a:rPr sz="1300" b="0">
+                <a:spcPts val="600"/>
+              </a:spcAft>
+            </a:pPr>
+            <a:r>
+              <a:rPr sz="1250" b="0">
                 <a:solidFill>
                   <a:srgbClr val="101828"/>
                 </a:solidFill>
                 <a:latin typeface="Microsoft JhengHei"/>
               </a:rPr>
-              <a:t>兩名副總與一名會計遭檢調帶走，搜索規模大，引發內控與治理爭議。</a:t>
+              <a:t>08/28：兩名副總與一名會計遭檢調帶走，看空者陳昆仁、黃豐凱、郭哲榮；黃豐凱預估跌至 900–1,000 元。</a:t>
             </a:r>
           </a:p>
           <a:p>
@@ -9300,17 +9356,17 @@
                 <a:spcPts val="0"/>
               </a:spcBef>
               <a:spcAft>
-                <a:spcPts val="700"/>
-              </a:spcAft>
-            </a:pPr>
-            <a:r>
-              <a:rPr sz="1400" b="1">
-                <a:solidFill>
-                  <a:srgbClr val="0F7A55"/>
-                </a:solidFill>
-                <a:latin typeface="Microsoft JhengHei"/>
-              </a:rPr>
-              <a:t>看空者：陳昆仁、黃豐凱、郭哲榮</a:t>
+                <a:spcPts val="600"/>
+              </a:spcAft>
+            </a:pPr>
+            <a:r>
+              <a:rPr sz="1300" b="1">
+                <a:solidFill>
+                  <a:srgbClr val="C1121F"/>
+                </a:solidFill>
+                <a:latin typeface="Microsoft JhengHei"/>
+              </a:rPr>
+              <a:t>週末釐清：涉嫌原產地標示不實（妨害農工商罪），不是做假帳，也不是洗產地。</a:t>
             </a:r>
           </a:p>
           <a:p>
@@ -9319,7 +9375,7 @@
                 <a:spcPts val="0"/>
               </a:spcBef>
               <a:spcAft>
-                <a:spcPts val="500"/>
+                <a:spcPts val="400"/>
               </a:spcAft>
             </a:pPr>
             <a:r>
@@ -9329,7 +9385,7 @@
                 </a:solidFill>
                 <a:latin typeface="Microsoft JhengHei"/>
               </a:rPr>
-              <a:t>黃豐凱：投信高持股且週五來不及調節，預估跌至 900–1,000 元；資金可能轉單至景碩（3189）避險</a:t>
+              <a:t>陳昆仁改口：週一跌停很可能是相對低點，爆量或打開跌停反而是買點，轉單南電、景碩是假議題。</a:t>
             </a:r>
           </a:p>
           <a:p>
@@ -9348,7 +9404,7 @@
                 </a:solidFill>
                 <a:latin typeface="Microsoft JhengHei"/>
               </a:rPr>
-              <a:t>郭哲榮：若僅個人內線是一天反應；若涉及假帳、營收灌水，可能連續跌停兩至三根</a:t>
+              <a:t>蔡明翰不同意：仍涉公司治理與財報可靠度，真相明朗前不加碼，持股逾一成應減碼。</a:t>
             </a:r>
           </a:p>
         </p:txBody>
@@ -9361,7 +9417,7 @@
         </p:nvSpPr>
         <p:spPr>
           <a:xfrm>
-            <a:off x="6492240" y="3840480"/>
+            <a:off x="6492240" y="4169663"/>
             <a:ext cx="5169103" cy="274320"/>
           </a:xfrm>
           <a:prstGeom prst="rect">
@@ -9403,8 +9459,8 @@
         </p:nvSpPr>
         <p:spPr>
           <a:xfrm>
-            <a:off x="6492240" y="4224528"/>
-            <a:ext cx="5169103" cy="566928"/>
+            <a:off x="6492240" y="4535424"/>
+            <a:ext cx="5169103" cy="749808"/>
           </a:xfrm>
           <a:prstGeom prst="rect">
             <a:avLst/>
@@ -9447,8 +9503,8 @@
         </p:nvSpPr>
         <p:spPr>
           <a:xfrm>
-            <a:off x="6693408" y="4334256"/>
-            <a:ext cx="4766767" cy="384048"/>
+            <a:off x="6693408" y="4645152"/>
+            <a:ext cx="4766767" cy="566928"/>
           </a:xfrm>
           <a:prstGeom prst="rect">
             <a:avLst/>
@@ -9473,7 +9529,7 @@
                 </a:solidFill>
                 <a:latin typeface="Microsoft JhengHei"/>
               </a:rPr>
-              <a:t>消費性電子　</a:t>
+              <a:t>9 月高本益比科技股　</a:t>
             </a:r>
             <a:r>
               <a:rPr sz="1200">
@@ -9482,7 +9538,26 @@
                 </a:solidFill>
                 <a:latin typeface="Microsoft JhengHei"/>
               </a:rPr>
-              <a:t>漲價壓力侵蝕購買力、拉貨不積極（容逸燊、游庭皓、蔚辰）</a:t>
+              <a:t>利率走高壓抑估值（林漢偉、蔡明翰、鍾國忠）</a:t>
+            </a:r>
+          </a:p>
+          <a:p>
+            <a:pPr algn="l">
+              <a:spcBef>
+                <a:spcPts val="0"/>
+              </a:spcBef>
+              <a:spcAft>
+                <a:spcPts val="0"/>
+              </a:spcAft>
+            </a:pPr>
+            <a:r>
+              <a:rPr sz="1200" b="1">
+                <a:solidFill>
+                  <a:srgbClr val="C1121F"/>
+                </a:solidFill>
+                <a:latin typeface="Microsoft JhengHei"/>
+              </a:rPr>
+              <a:t>週末新增的一致看空</a:t>
             </a:r>
           </a:p>
         </p:txBody>
@@ -9495,8 +9570,8 @@
         </p:nvSpPr>
         <p:spPr>
           <a:xfrm>
-            <a:off x="6492240" y="4901184"/>
-            <a:ext cx="5169103" cy="786384"/>
+            <a:off x="6492240" y="5394960"/>
+            <a:ext cx="5169103" cy="914400"/>
           </a:xfrm>
           <a:prstGeom prst="rect">
             <a:avLst/>
@@ -9539,8 +9614,8 @@
         </p:nvSpPr>
         <p:spPr>
           <a:xfrm>
-            <a:off x="6693408" y="5010912"/>
-            <a:ext cx="4766767" cy="603504"/>
+            <a:off x="6693408" y="5504688"/>
+            <a:ext cx="4766767" cy="731520"/>
           </a:xfrm>
           <a:prstGeom prst="rect">
             <a:avLst/>
@@ -9574,7 +9649,7 @@
                 </a:solidFill>
                 <a:latin typeface="Microsoft JhengHei"/>
               </a:rPr>
-              <a:t>老王、郭哲榮、陳昆仁、祥維看空；容逸燊、黃豐凱在 08/28 看多聯電</a:t>
+              <a:t>老王、郭哲榮、陳昆仁、祥維看空；容逸燊、黃豐凱看多聯電，週末林漢偉、陳昆仁也站到看多那邊</a:t>
             </a:r>
           </a:p>
           <a:p>
@@ -10123,7 +10198,26 @@
                 </a:solidFill>
                 <a:latin typeface="Microsoft JhengHei"/>
               </a:rPr>
-              <a:t>矽晶圓基本面</a:t>
+              <a:t>欣興（3037）</a:t>
+            </a:r>
+          </a:p>
+          <a:p>
+            <a:pPr algn="l">
+              <a:spcBef>
+                <a:spcPts val="0"/>
+              </a:spcBef>
+              <a:spcAft>
+                <a:spcPts val="0"/>
+              </a:spcAft>
+            </a:pPr>
+            <a:r>
+              <a:rPr sz="1150" b="0">
+                <a:solidFill>
+                  <a:srgbClr val="5B6472"/>
+                </a:solidFill>
+                <a:latin typeface="Microsoft JhengHei"/>
+              </a:rPr>
+              <a:t>週末新增</a:t>
             </a:r>
           </a:p>
         </p:txBody>
@@ -10209,7 +10303,7 @@
                 </a:solidFill>
                 <a:latin typeface="Microsoft JhengHei"/>
               </a:rPr>
-              <a:t>郭哲榮、劉育綸：現貨雙位數大漲、產能滿載、合約洽談中，17 天內信號全面轉正</a:t>
+              <a:t>陳昆仁：只是原產地標示不實，週一跌停很可能是相對低點，打開跌停反而是買點</a:t>
             </a:r>
           </a:p>
         </p:txBody>
@@ -10295,7 +10389,7 @@
                 </a:solidFill>
                 <a:latin typeface="Microsoft JhengHei"/>
               </a:rPr>
-              <a:t>蔡明翰：營收與獲利在所有族群中最弱，純屬預期，拉回「絕對不要向下攤平」</a:t>
+              <a:t>蔡明翰：涉及公司治理與財報可靠度，真相明朗前不加碼，持股逾一成應減碼</a:t>
             </a:r>
           </a:p>
         </p:txBody>
@@ -10381,7 +10475,26 @@
                 </a:solidFill>
                 <a:latin typeface="Microsoft JhengHei"/>
               </a:rPr>
-              <a:t>高檔熱門股要不要追</a:t>
+              <a:t>台幣升值的衝擊</a:t>
+            </a:r>
+          </a:p>
+          <a:p>
+            <a:pPr algn="l">
+              <a:spcBef>
+                <a:spcPts val="0"/>
+              </a:spcBef>
+              <a:spcAft>
+                <a:spcPts val="0"/>
+              </a:spcAft>
+            </a:pPr>
+            <a:r>
+              <a:rPr sz="1150" b="0">
+                <a:solidFill>
+                  <a:srgbClr val="5B6472"/>
+                </a:solidFill>
+                <a:latin typeface="Microsoft JhengHei"/>
+              </a:rPr>
+              <a:t>週末新增</a:t>
             </a:r>
           </a:p>
         </p:txBody>
@@ -10467,7 +10580,7 @@
                 </a:solidFill>
                 <a:latin typeface="Microsoft JhengHei"/>
               </a:rPr>
-              <a:t>林漢偉：順著強勢產業趨勢做，領頭羊先創高，背後有大資金帶動</a:t>
+              <a:t>林漢偉：基本面依然亮眼，7 月外銷訂單將破 1,000 億美元，8–10 月營收創高機會高</a:t>
             </a:r>
           </a:p>
         </p:txBody>
@@ -10553,7 +10666,7 @@
                 </a:solidFill>
                 <a:latin typeface="Microsoft JhengHei"/>
               </a:rPr>
-              <a:t>容逸燊：聯亞、大立光短線已拉數根漲停，賺賠比不划算，轉向低位階個股</a:t>
+              <a:t>鍾國忠：8 月台幣升值近 2%，衝擊第三季出口商利潤，9/10 公布的營收可能不如預期</a:t>
             </a:r>
           </a:p>
         </p:txBody>
@@ -10639,26 +10752,7 @@
                 </a:solidFill>
                 <a:latin typeface="Microsoft JhengHei"/>
               </a:rPr>
-              <a:t>國巨（2327）</a:t>
-            </a:r>
-          </a:p>
-          <a:p>
-            <a:pPr algn="l">
-              <a:spcBef>
-                <a:spcPts val="0"/>
-              </a:spcBef>
-              <a:spcAft>
-                <a:spcPts val="0"/>
-              </a:spcAft>
-            </a:pPr>
-            <a:r>
-              <a:rPr sz="1150" b="0">
-                <a:solidFill>
-                  <a:srgbClr val="5B6472"/>
-                </a:solidFill>
-                <a:latin typeface="Microsoft JhengHei"/>
-              </a:rPr>
-              <a:t>被動元件</a:t>
+              <a:t>矽晶圓基本面</a:t>
             </a:r>
           </a:p>
         </p:txBody>
@@ -10744,7 +10838,7 @@
                 </a:solidFill>
                 <a:latin typeface="Microsoft JhengHei"/>
               </a:rPr>
-              <a:t>郭哲榮：1,000 元以上有 30 萬人套牢，反覆洗盤，拉回即買點</a:t>
+              <a:t>郭哲榮、劉育綸：現貨雙位數大漲、產能滿載、合約洽談中，17 天內信號全面轉正</a:t>
             </a:r>
           </a:p>
         </p:txBody>
@@ -10830,7 +10924,7 @@
                 </a:solidFill>
                 <a:latin typeface="Microsoft JhengHei"/>
               </a:rPr>
-              <a:t>老王、劉育綸（08/25）：跌破三短均線「三聲無奈」，土洋同賣、散戶攤平為反指標</a:t>
+              <a:t>蔡明翰：營收與獲利在所有族群中最弱，純屬預期，拉回「絕對不要向下攤平」</a:t>
             </a:r>
           </a:p>
         </p:txBody>
@@ -11174,7 +11268,7 @@
                 </a:solidFill>
                 <a:latin typeface="Microsoft JhengHei"/>
               </a:rPr>
-              <a:t>被動元件是唯一在週內收斂的分歧：08/25 還在吵，08/28 變成當日看多人數最多的族群。</a:t>
+              <a:t>被動元件是唯一收斂掉的分歧：08/25 還在吵國巨，08/28 變成當日看多人數最多的族群；欣興則是反過來，從單向看空長出新的分歧。</a:t>
             </a:r>
           </a:p>
         </p:txBody>
@@ -11620,7 +11714,7 @@
                 </a:solidFill>
                 <a:latin typeface="Microsoft JhengHei"/>
               </a:rPr>
-              <a:t>MSCI 季度調整生效</a:t>
+              <a:t>MSCI 季度調整生效 ＋ 放鷹後首個交易日</a:t>
             </a:r>
           </a:p>
         </p:txBody>
@@ -11662,7 +11756,7 @@
                 </a:solidFill>
                 <a:latin typeface="Microsoft JhengHei"/>
               </a:rPr>
-              <a:t>林漢偉：補量關鍵日，預估成交量 1.1 至 1.2 兆元</a:t>
+              <a:t>林漢偉：補量關鍵日，預估 1.1 至 1.2 兆元｜陳昆仁：多空爆量震盪</a:t>
             </a:r>
           </a:p>
         </p:txBody>
@@ -11726,7 +11820,7 @@
             <a:avLst/>
           </a:prstGeom>
           <a:solidFill>
-            <a:srgbClr val="C1121F"/>
+            <a:srgbClr val="0F7A55"/>
           </a:solidFill>
           <a:ln>
             <a:noFill/>
@@ -11788,11 +11882,11 @@
             <a:r>
               <a:rPr sz="1350" b="1">
                 <a:solidFill>
-                  <a:srgbClr val="C1121F"/>
+                  <a:srgbClr val="0F7A55"/>
                 </a:solidFill>
                 <a:latin typeface="Consolas"/>
               </a:rPr>
-              <a:t>08/31 (一)</a:t>
+              <a:t>本週</a:t>
             </a:r>
           </a:p>
         </p:txBody>
@@ -11834,7 +11928,7 @@
                 </a:solidFill>
                 <a:latin typeface="Microsoft JhengHei"/>
               </a:rPr>
-              <a:t>矽光子國際論壇</a:t>
+              <a:t>美國新增就業報告、超微與博通財報</a:t>
             </a:r>
           </a:p>
         </p:txBody>
@@ -11876,7 +11970,7 @@
                 </a:solidFill>
                 <a:latin typeface="Microsoft JhengHei"/>
               </a:rPr>
-              <a:t>陳昆仁：CPO 商轉元年，提前布局</a:t>
+              <a:t>蔡明翰：新增就業預估 6.5 萬人；博通若上修 TPU 訂單，利多台積電與聯發科</a:t>
             </a:r>
           </a:p>
         </p:txBody>
@@ -12090,7 +12184,7 @@
                 </a:solidFill>
                 <a:latin typeface="Microsoft JhengHei"/>
               </a:rPr>
-              <a:t>陳昆仁、容逸燊、陳唯泰：設備與 CPO 族群題材期</a:t>
+              <a:t>林漢偉、陳昆仁、鍾國忠：設備、先進封裝與 CPO 題材期</a:t>
             </a:r>
           </a:p>
         </p:txBody>
@@ -12220,7 +12314,7 @@
                 </a:solidFill>
                 <a:latin typeface="Consolas"/>
               </a:rPr>
-              <a:t>09/03 (四)</a:t>
+              <a:t>09/04 (五) 前</a:t>
             </a:r>
           </a:p>
         </p:txBody>
@@ -12262,7 +12356,7 @@
                 </a:solidFill>
                 <a:latin typeface="Microsoft JhengHei"/>
               </a:rPr>
-              <a:t>中光電投控（3718）換股掛牌</a:t>
+              <a:t>南亞科公布 8 月營收</a:t>
             </a:r>
           </a:p>
         </p:txBody>
@@ -12304,7 +12398,7 @@
                 </a:solidFill>
                 <a:latin typeface="Microsoft JhengHei"/>
               </a:rPr>
-              <a:t>鍾國忠</a:t>
+              <a:t>林漢偉：記憶體現貨價走高，觀察營收能否對上</a:t>
             </a:r>
           </a:p>
         </p:txBody>
@@ -12518,7 +12612,7 @@
                 </a:solidFill>
                 <a:latin typeface="Microsoft JhengHei"/>
               </a:rPr>
-              <a:t>游庭皓、林漢偉：等同變相寬鬆，利於台幣升值與外資回流</a:t>
+              <a:t>游庭皓、林漢偉：等同變相寬鬆｜M 平方 Viv：對 40 兆美元債務規模是杯水車薪</a:t>
             </a:r>
           </a:p>
         </p:txBody>
@@ -12690,7 +12784,7 @@
                 </a:solidFill>
                 <a:latin typeface="Microsoft JhengHei"/>
               </a:rPr>
-              <a:t>蘋果 iPhone 18 系列與折疊機發表會</a:t>
+              <a:t>蘋果發表會 ＋ 台廠 8 月營收公布</a:t>
             </a:r>
           </a:p>
         </p:txBody>
@@ -12732,7 +12826,7 @@
                 </a:solidFill>
                 <a:latin typeface="Microsoft JhengHei"/>
               </a:rPr>
-              <a:t>林漢偉、陳昆仁、陳唯泰：光學、折疊機鉸鏈、軸承族群</a:t>
+              <a:t>林漢偉、鍾國忠：光學與折疊機族群；台幣升值的衝擊會在這天見真章</a:t>
             </a:r>
           </a:p>
         </p:txBody>
@@ -12796,7 +12890,7 @@
             <a:avLst/>
           </a:prstGeom>
           <a:solidFill>
-            <a:srgbClr val="0C2340"/>
+            <a:srgbClr val="0F7A55"/>
           </a:solidFill>
           <a:ln>
             <a:noFill/>
@@ -12858,11 +12952,11 @@
             <a:r>
               <a:rPr sz="1350" b="1">
                 <a:solidFill>
-                  <a:srgbClr val="0C2340"/>
+                  <a:srgbClr val="0F7A55"/>
                 </a:solidFill>
                 <a:latin typeface="Consolas"/>
               </a:rPr>
-              <a:t>09/15 (二)</a:t>
+              <a:t>09/24 (四)</a:t>
             </a:r>
           </a:p>
         </p:txBody>
@@ -12904,7 +12998,7 @@
                 </a:solidFill>
                 <a:latin typeface="Microsoft JhengHei"/>
               </a:rPr>
-              <a:t>台北航太展</a:t>
+              <a:t>川習會</a:t>
             </a:r>
           </a:p>
         </p:txBody>
@@ -12946,7 +13040,7 @@
                 </a:solidFill>
                 <a:latin typeface="Microsoft JhengHei"/>
               </a:rPr>
-              <a:t>鍾國忠：無人機預算商機</a:t>
+              <a:t>游庭皓、陳昆仁：記憶體與關稅的政治風險點</a:t>
             </a:r>
           </a:p>
         </p:txBody>
@@ -13076,7 +13170,7 @@
                 </a:solidFill>
                 <a:latin typeface="Consolas"/>
               </a:rPr>
-              <a:t>09/24 (四)</a:t>
+              <a:t>九月下旬</a:t>
             </a:r>
           </a:p>
         </p:txBody>
@@ -13118,7 +13212,7 @@
                 </a:solidFill>
                 <a:latin typeface="Microsoft JhengHei"/>
               </a:rPr>
-              <a:t>川習會</a:t>
+              <a:t>台灣央行理事會、日圓可能升息</a:t>
             </a:r>
           </a:p>
         </p:txBody>
@@ -13160,7 +13254,7 @@
                 </a:solidFill>
                 <a:latin typeface="Microsoft JhengHei"/>
               </a:rPr>
-              <a:t>游庭皓、陳昆仁：記憶體與關稅的政治風險點</a:t>
+              <a:t>鍾國忠</a:t>
             </a:r>
           </a:p>
         </p:txBody>
@@ -13332,7 +13426,7 @@
                 </a:solidFill>
                 <a:latin typeface="Microsoft JhengHei"/>
               </a:rPr>
-              <a:t>投信季底作帳、Fed 會議、日銀升息</a:t>
+              <a:t>Fed 利率會議</a:t>
             </a:r>
           </a:p>
         </p:txBody>
@@ -13374,7 +13468,7 @@
                 </a:solidFill>
                 <a:latin typeface="Microsoft JhengHei"/>
               </a:rPr>
-              <a:t>王建文、紀緯明、鍾國忠</a:t>
+              <a:t>升息機率已被定價在 57–60%（林漢偉、陳昆仁、蔡明翰）</a:t>
             </a:r>
           </a:p>
         </p:txBody>
@@ -13648,7 +13742,7 @@
                 </a:solidFill>
                 <a:latin typeface="Microsoft JhengHei"/>
               </a:rPr>
-              <a:t>沒有結論，只有各自畫出來的線</a:t>
+              <a:t>以週末節目為準，同一個 46,000 點兩種讀法</a:t>
             </a:r>
           </a:p>
         </p:txBody>
@@ -13748,7 +13842,7 @@
         <p:spPr>
           <a:xfrm>
             <a:off x="530352" y="1755648"/>
-            <a:ext cx="5532120" cy="658368"/>
+            <a:ext cx="5532120" cy="804672"/>
           </a:xfrm>
           <a:prstGeom prst="rect">
             <a:avLst/>
@@ -13792,7 +13886,7 @@
         <p:spPr>
           <a:xfrm>
             <a:off x="731520" y="1865376"/>
-            <a:ext cx="5129784" cy="475488"/>
+            <a:ext cx="5129784" cy="621792"/>
           </a:xfrm>
           <a:prstGeom prst="rect">
             <a:avLst/>
@@ -13845,7 +13939,7 @@
                 </a:solidFill>
                 <a:latin typeface="Microsoft JhengHei"/>
               </a:rPr>
-              <a:t>站穩 46,325 點，均線重回多頭排列，九月第一週有機會突破 48,218 點</a:t>
+              <a:t>跌破 46,000 點未破壞多方結構，5 日線附近有強力支撐，回撤對盤勢是好事，拉回反而提供低接買點</a:t>
             </a:r>
           </a:p>
         </p:txBody>
@@ -13858,8 +13952,8 @@
         </p:nvSpPr>
         <p:spPr>
           <a:xfrm>
-            <a:off x="530352" y="2487168"/>
-            <a:ext cx="5532120" cy="841248"/>
+            <a:off x="530352" y="2615184"/>
+            <a:ext cx="5532120" cy="804672"/>
           </a:xfrm>
           <a:prstGeom prst="rect">
             <a:avLst/>
@@ -13902,8 +13996,8 @@
         </p:nvSpPr>
         <p:spPr>
           <a:xfrm>
-            <a:off x="731520" y="2596896"/>
-            <a:ext cx="5129784" cy="658368"/>
+            <a:off x="731520" y="2724912"/>
+            <a:ext cx="5129784" cy="621792"/>
           </a:xfrm>
           <a:prstGeom prst="rect">
             <a:avLst/>
@@ -13928,7 +14022,7 @@
                 </a:solidFill>
                 <a:latin typeface="Microsoft JhengHei"/>
               </a:rPr>
-              <a:t>高憲容　</a:t>
+              <a:t>陳昆仁　</a:t>
             </a:r>
             <a:r>
               <a:rPr sz="1150">
@@ -13956,7 +14050,7 @@
                 </a:solidFill>
                 <a:latin typeface="Microsoft JhengHei"/>
               </a:rPr>
-              <a:t>台幣轉升 ＋ 外資史上最大買超，依 2022/11、2023/11、2025/5 三次經驗，可啟動 7–10 個月、漲幅 38%–105% 的波段，台股看 54,000 點</a:t>
+              <a:t>升息利空已被快速定價，是短線情緒釋放；融資連日暴增代表散戶進場，主力洗盤是必然，不是系統性盤整</a:t>
             </a:r>
           </a:p>
         </p:txBody>
@@ -13969,8 +14063,8 @@
         </p:nvSpPr>
         <p:spPr>
           <a:xfrm>
-            <a:off x="530352" y="3401568"/>
-            <a:ext cx="5532120" cy="658368"/>
+            <a:off x="530352" y="3474720"/>
+            <a:ext cx="5532120" cy="804672"/>
           </a:xfrm>
           <a:prstGeom prst="rect">
             <a:avLst/>
@@ -14013,8 +14107,8 @@
         </p:nvSpPr>
         <p:spPr>
           <a:xfrm>
-            <a:off x="731520" y="3511296"/>
-            <a:ext cx="5129784" cy="475488"/>
+            <a:off x="731520" y="3584448"/>
+            <a:ext cx="5129784" cy="621792"/>
           </a:xfrm>
           <a:prstGeom prst="rect">
             <a:avLst/>
@@ -14039,7 +14133,7 @@
                 </a:solidFill>
                 <a:latin typeface="Microsoft JhengHei"/>
               </a:rPr>
-              <a:t>郭哲榮　</a:t>
+              <a:t>高憲容　</a:t>
             </a:r>
             <a:r>
               <a:rPr sz="1150">
@@ -14067,7 +14161,7 @@
                 </a:solidFill>
                 <a:latin typeface="Microsoft JhengHei"/>
               </a:rPr>
-              <a:t>下週被動元件大補漲；年底看 5 萬點</a:t>
+              <a:t>台幣轉升 ＋ 外資史上最大買超，依三次歷史經驗可啟動 7–10 個月的波段，台股看 54,000 點</a:t>
             </a:r>
           </a:p>
         </p:txBody>
@@ -14080,8 +14174,8 @@
         </p:nvSpPr>
         <p:spPr>
           <a:xfrm>
-            <a:off x="530352" y="4133088"/>
-            <a:ext cx="5532120" cy="658368"/>
+            <a:off x="530352" y="4334256"/>
+            <a:ext cx="5532120" cy="640080"/>
           </a:xfrm>
           <a:prstGeom prst="rect">
             <a:avLst/>
@@ -14124,8 +14218,8 @@
         </p:nvSpPr>
         <p:spPr>
           <a:xfrm>
-            <a:off x="731520" y="4242816"/>
-            <a:ext cx="5129784" cy="475488"/>
+            <a:off x="731520" y="4443984"/>
+            <a:ext cx="5129784" cy="457200"/>
           </a:xfrm>
           <a:prstGeom prst="rect">
             <a:avLst/>
@@ -14150,7 +14244,7 @@
                 </a:solidFill>
                 <a:latin typeface="Microsoft JhengHei"/>
               </a:rPr>
-              <a:t>容逸燊　</a:t>
+              <a:t>郭哲榮　</a:t>
             </a:r>
             <a:r>
               <a:rPr sz="1150">
@@ -14178,7 +14272,7 @@
                 </a:solidFill>
                 <a:latin typeface="Microsoft JhengHei"/>
               </a:rPr>
-              <a:t>九月資金轉向低基期的工具機、被動元件、成熟製程</a:t>
+              <a:t>下週被動元件大補漲；年底看 5 萬點</a:t>
             </a:r>
           </a:p>
         </p:txBody>
@@ -14278,7 +14372,7 @@
         <p:spPr>
           <a:xfrm>
             <a:off x="6272784" y="1755648"/>
-            <a:ext cx="5532120" cy="841248"/>
+            <a:ext cx="5532120" cy="804672"/>
           </a:xfrm>
           <a:prstGeom prst="rect">
             <a:avLst/>
@@ -14322,7 +14416,7 @@
         <p:spPr>
           <a:xfrm>
             <a:off x="6473952" y="1865376"/>
-            <a:ext cx="5129784" cy="658368"/>
+            <a:ext cx="5129784" cy="621792"/>
           </a:xfrm>
           <a:prstGeom prst="rect">
             <a:avLst/>
@@ -14375,7 +14469,7 @@
                 </a:solidFill>
                 <a:latin typeface="Microsoft JhengHei"/>
               </a:rPr>
-              <a:t>46,350 點以上追高將面臨巨大賣壓，需 1.1 兆換手量；建議逢高減碼、保留現金</a:t>
+              <a:t>指數高於 46,000 點應把持股降到 4 成；拉回 42,000 點再拉高到 8–9 成。8 月量 17 兆低於 7 月 21 兆，無量難以大漲</a:t>
             </a:r>
           </a:p>
         </p:txBody>
@@ -14388,8 +14482,8 @@
         </p:nvSpPr>
         <p:spPr>
           <a:xfrm>
-            <a:off x="6272784" y="2670048"/>
-            <a:ext cx="5532120" cy="841248"/>
+            <a:off x="6272784" y="2615184"/>
+            <a:ext cx="5532120" cy="804672"/>
           </a:xfrm>
           <a:prstGeom prst="rect">
             <a:avLst/>
@@ -14432,8 +14526,8 @@
         </p:nvSpPr>
         <p:spPr>
           <a:xfrm>
-            <a:off x="6473952" y="2779776"/>
-            <a:ext cx="5129784" cy="658368"/>
+            <a:off x="6473952" y="2724912"/>
+            <a:ext cx="5129784" cy="621792"/>
           </a:xfrm>
           <a:prstGeom prst="rect">
             <a:avLst/>
@@ -14458,7 +14552,7 @@
                 </a:solidFill>
                 <a:latin typeface="Microsoft JhengHei"/>
               </a:rPr>
-              <a:t>囿羽　</a:t>
+              <a:t>蔡明翰　</a:t>
             </a:r>
             <a:r>
               <a:rPr sz="1150">
@@ -14467,7 +14561,7 @@
                 </a:solidFill>
                 <a:latin typeface="Microsoft JhengHei"/>
               </a:rPr>
-              <a:t>偏多／信心中</a:t>
+              <a:t>中性／信心中</a:t>
             </a:r>
           </a:p>
           <a:p>
@@ -14486,7 +14580,7 @@
                 </a:solidFill>
                 <a:latin typeface="Microsoft JhengHei"/>
               </a:rPr>
-              <a:t>量能與 KD 雙背離、季線仍下彎、下週布林通道高檔收窄，觀察日 KD 能否化解背離</a:t>
+              <a:t>通膨具黏性、美債殖利率維持 5% 以上，估值持續受壓；9 月有望以高檔整理取代大跌，但槓桿不要開滿</a:t>
             </a:r>
           </a:p>
         </p:txBody>
@@ -14499,8 +14593,8 @@
         </p:nvSpPr>
         <p:spPr>
           <a:xfrm>
-            <a:off x="6272784" y="3584448"/>
-            <a:ext cx="5532120" cy="841248"/>
+            <a:off x="6272784" y="3474720"/>
+            <a:ext cx="5532120" cy="640080"/>
           </a:xfrm>
           <a:prstGeom prst="rect">
             <a:avLst/>
@@ -14543,8 +14637,8 @@
         </p:nvSpPr>
         <p:spPr>
           <a:xfrm>
-            <a:off x="6473952" y="3694176"/>
-            <a:ext cx="5129784" cy="658368"/>
+            <a:off x="6473952" y="3584448"/>
+            <a:ext cx="5129784" cy="457200"/>
           </a:xfrm>
           <a:prstGeom prst="rect">
             <a:avLst/>
@@ -14569,7 +14663,7 @@
                 </a:solidFill>
                 <a:latin typeface="Microsoft JhengHei"/>
               </a:rPr>
-              <a:t>劉育綸　</a:t>
+              <a:t>囿羽　</a:t>
             </a:r>
             <a:r>
               <a:rPr sz="1150">
@@ -14578,7 +14672,7 @@
                 </a:solidFill>
                 <a:latin typeface="Microsoft JhengHei"/>
               </a:rPr>
-              <a:t>中性／信心中</a:t>
+              <a:t>偏多／信心中</a:t>
             </a:r>
           </a:p>
           <a:p>
@@ -14597,7 +14691,7 @@
                 </a:solidFill>
                 <a:latin typeface="Microsoft JhengHei"/>
               </a:rPr>
-              <a:t>若跌破當日低點，將進入 44,200–46,400 點的箱型整理，「創高不追、回落敢買」</a:t>
+              <a:t>量能與 KD 雙背離、季線下彎、布林通道高檔收窄，觀察日 KD 能否化解</a:t>
             </a:r>
           </a:p>
         </p:txBody>
@@ -14610,8 +14704,8 @@
         </p:nvSpPr>
         <p:spPr>
           <a:xfrm>
-            <a:off x="6272784" y="4498848"/>
-            <a:ext cx="5532120" cy="658368"/>
+            <a:off x="6272784" y="4169664"/>
+            <a:ext cx="5532120" cy="640080"/>
           </a:xfrm>
           <a:prstGeom prst="rect">
             <a:avLst/>
@@ -14654,8 +14748,8 @@
         </p:nvSpPr>
         <p:spPr>
           <a:xfrm>
-            <a:off x="6473952" y="4608576"/>
-            <a:ext cx="5129784" cy="475488"/>
+            <a:off x="6473952" y="4279392"/>
+            <a:ext cx="5129784" cy="457200"/>
           </a:xfrm>
           <a:prstGeom prst="rect">
             <a:avLst/>
@@ -14680,7 +14774,7 @@
                 </a:solidFill>
                 <a:latin typeface="Microsoft JhengHei"/>
               </a:rPr>
-              <a:t>陳昆仁　</a:t>
+              <a:t>劉育綸　</a:t>
             </a:r>
             <a:r>
               <a:rPr sz="1150">
@@ -14689,7 +14783,7 @@
                 </a:solidFill>
                 <a:latin typeface="Microsoft JhengHei"/>
               </a:rPr>
-              <a:t>偏多／信心中</a:t>
+              <a:t>中性／信心中</a:t>
             </a:r>
           </a:p>
           <a:p>
@@ -14708,7 +14802,7 @@
                 </a:solidFill>
                 <a:latin typeface="Microsoft JhengHei"/>
               </a:rPr>
-              <a:t>前波七月套牢量大，短線有震盪與獲利了結賣壓</a:t>
+              <a:t>若跌破低點將進入 44,200–46,400 點箱型整理，創高不追、回落敢買</a:t>
             </a:r>
           </a:p>
         </p:txBody>
@@ -14765,8 +14859,8 @@
         </p:nvSpPr>
         <p:spPr>
           <a:xfrm>
-            <a:off x="786384" y="5358384"/>
-            <a:ext cx="4023360" cy="310896"/>
+            <a:off x="786384" y="5340096"/>
+            <a:ext cx="4206240" cy="822960"/>
           </a:xfrm>
           <a:prstGeom prst="rect">
             <a:avLst/>
@@ -14784,7 +14878,7 @@
                 <a:spcPts val="0"/>
               </a:spcBef>
               <a:spcAft>
-                <a:spcPts val="0"/>
+                <a:spcPts val="400"/>
               </a:spcAft>
             </a:pPr>
             <a:r>
@@ -14794,7 +14888,26 @@
                 </a:solidFill>
                 <a:latin typeface="Microsoft JhengHei"/>
               </a:rPr>
-              <a:t>多空雙方其實在講同一件事：量。</a:t>
+              <a:t>分界線是同一個數字：46,000 點。</a:t>
+            </a:r>
+          </a:p>
+          <a:p>
+            <a:pPr algn="l">
+              <a:spcBef>
+                <a:spcPts val="0"/>
+              </a:spcBef>
+              <a:spcAft>
+                <a:spcPts val="0"/>
+              </a:spcAft>
+            </a:pPr>
+            <a:r>
+              <a:rPr sz="1200" b="0">
+                <a:solidFill>
+                  <a:srgbClr val="9FB3CC"/>
+                </a:solidFill>
+                <a:latin typeface="Microsoft JhengHei"/>
+              </a:rPr>
+              <a:t>一邊說跌破了也不破壞結構、拉回是買點；另一邊說站上了就該減碼。</a:t>
             </a:r>
           </a:p>
         </p:txBody>
@@ -14807,7 +14920,7 @@
         </p:nvSpPr>
         <p:spPr>
           <a:xfrm>
-            <a:off x="5010912" y="5358384"/>
+            <a:off x="5193792" y="5358384"/>
             <a:ext cx="25400" cy="786384"/>
           </a:xfrm>
           <a:prstGeom prst="rect">
@@ -14851,8 +14964,8 @@
         </p:nvSpPr>
         <p:spPr>
           <a:xfrm>
-            <a:off x="5138928" y="5358384"/>
-            <a:ext cx="1517904" cy="786384"/>
+            <a:off x="5321808" y="5376672"/>
+            <a:ext cx="1481328" cy="786384"/>
           </a:xfrm>
           <a:prstGeom prst="rect">
             <a:avLst/>
@@ -14880,7 +14993,7 @@
                 </a:solidFill>
                 <a:latin typeface="Consolas"/>
               </a:rPr>
-              <a:t>8,500 億–1 兆</a:t>
+              <a:t>46,000</a:t>
             </a:r>
           </a:p>
           <a:p>
@@ -14893,13 +15006,13 @@
               </a:spcAft>
             </a:pPr>
             <a:r>
-              <a:rPr sz="1100" b="0">
+              <a:rPr sz="1050" b="0">
                 <a:solidFill>
                   <a:srgbClr val="9FB3CC"/>
                 </a:solidFill>
                 <a:latin typeface="Microsoft JhengHei"/>
               </a:rPr>
-              <a:t>劉育綸　進攻訊號</a:t>
+              <a:t>林漢偉　跌破不破壞結構</a:t>
             </a:r>
           </a:p>
         </p:txBody>
@@ -14912,14 +15025,14 @@
         </p:nvSpPr>
         <p:spPr>
           <a:xfrm>
-            <a:off x="6702552" y="5358384"/>
+            <a:off x="6839712" y="5358384"/>
             <a:ext cx="25400" cy="786384"/>
           </a:xfrm>
           <a:prstGeom prst="rect">
             <a:avLst/>
           </a:prstGeom>
           <a:solidFill>
-            <a:srgbClr val="C1121F"/>
+            <a:srgbClr val="0F7A55"/>
           </a:solidFill>
           <a:ln>
             <a:noFill/>
@@ -14956,8 +15069,8 @@
         </p:nvSpPr>
         <p:spPr>
           <a:xfrm>
-            <a:off x="6830568" y="5358384"/>
-            <a:ext cx="1517904" cy="786384"/>
+            <a:off x="6967728" y="5376672"/>
+            <a:ext cx="1481328" cy="786384"/>
           </a:xfrm>
           <a:prstGeom prst="rect">
             <a:avLst/>
@@ -14985,7 +15098,7 @@
                 </a:solidFill>
                 <a:latin typeface="Consolas"/>
               </a:rPr>
-              <a:t>1.1 兆</a:t>
+              <a:t>46,000</a:t>
             </a:r>
           </a:p>
           <a:p>
@@ -14998,13 +15111,13 @@
               </a:spcAft>
             </a:pPr>
             <a:r>
-              <a:rPr sz="1100" b="0">
+              <a:rPr sz="1050" b="0">
                 <a:solidFill>
                   <a:srgbClr val="9FB3CC"/>
                 </a:solidFill>
                 <a:latin typeface="Microsoft JhengHei"/>
               </a:rPr>
-              <a:t>鍾國忠　換手門檻</a:t>
+              <a:t>鍾國忠　以上降到 4 成</a:t>
             </a:r>
           </a:p>
         </p:txBody>
@@ -15017,14 +15130,14 @@
         </p:nvSpPr>
         <p:spPr>
           <a:xfrm>
-            <a:off x="8394192" y="5358384"/>
+            <a:off x="8485632" y="5358384"/>
             <a:ext cx="25400" cy="786384"/>
           </a:xfrm>
           <a:prstGeom prst="rect">
             <a:avLst/>
           </a:prstGeom>
           <a:solidFill>
-            <a:srgbClr val="C1121F"/>
+            <a:srgbClr val="0F7A55"/>
           </a:solidFill>
           <a:ln>
             <a:noFill/>
@@ -15061,8 +15174,8 @@
         </p:nvSpPr>
         <p:spPr>
           <a:xfrm>
-            <a:off x="8522208" y="5358384"/>
-            <a:ext cx="1517904" cy="786384"/>
+            <a:off x="8613648" y="5376672"/>
+            <a:ext cx="1481328" cy="786384"/>
           </a:xfrm>
           <a:prstGeom prst="rect">
             <a:avLst/>
@@ -15090,7 +15203,7 @@
                 </a:solidFill>
                 <a:latin typeface="Consolas"/>
               </a:rPr>
-              <a:t>1.1–1.2 兆</a:t>
+              <a:t>42,000</a:t>
             </a:r>
           </a:p>
           <a:p>
@@ -15103,13 +15216,13 @@
               </a:spcAft>
             </a:pPr>
             <a:r>
-              <a:rPr sz="1100" b="0">
+              <a:rPr sz="1050" b="0">
                 <a:solidFill>
                   <a:srgbClr val="9FB3CC"/>
                 </a:solidFill>
                 <a:latin typeface="Microsoft JhengHei"/>
               </a:rPr>
-              <a:t>林漢偉　MSCI 補量</a:t>
+              <a:t>鍾國忠　才拉到 8–9 成</a:t>
             </a:r>
           </a:p>
         </p:txBody>
@@ -15122,14 +15235,14 @@
         </p:nvSpPr>
         <p:spPr>
           <a:xfrm>
-            <a:off x="10085832" y="5358384"/>
+            <a:off x="10131552" y="5358384"/>
             <a:ext cx="25400" cy="786384"/>
           </a:xfrm>
           <a:prstGeom prst="rect">
             <a:avLst/>
           </a:prstGeom>
           <a:solidFill>
-            <a:srgbClr val="C1121F"/>
+            <a:srgbClr val="0F7A55"/>
           </a:solidFill>
           <a:ln>
             <a:noFill/>
@@ -15166,8 +15279,8 @@
         </p:nvSpPr>
         <p:spPr>
           <a:xfrm>
-            <a:off x="10213848" y="5358384"/>
-            <a:ext cx="1517904" cy="786384"/>
+            <a:off x="10259568" y="5376672"/>
+            <a:ext cx="1481328" cy="786384"/>
           </a:xfrm>
           <a:prstGeom prst="rect">
             <a:avLst/>
@@ -15195,7 +15308,7 @@
                 </a:solidFill>
                 <a:latin typeface="Consolas"/>
               </a:rPr>
-              <a:t>1.2 兆</a:t>
+              <a:t>57–60%</a:t>
             </a:r>
           </a:p>
           <a:p>
@@ -15208,13 +15321,13 @@
               </a:spcAft>
             </a:pPr>
             <a:r>
-              <a:rPr sz="1100" b="0">
+              <a:rPr sz="1050" b="0">
                 <a:solidFill>
                   <a:srgbClr val="9FB3CC"/>
                 </a:solidFill>
                 <a:latin typeface="Microsoft JhengHei"/>
               </a:rPr>
-              <a:t>容逸燊　站穩新高</a:t>
+              <a:t>9 月升息機率已定價</a:t>
             </a:r>
           </a:p>
         </p:txBody>
@@ -15593,7 +15706,7 @@
                 </a:solidFill>
                 <a:latin typeface="Consolas"/>
               </a:rPr>
-              <a:t>…　20260825　20260826　20260827　…</a:t>
+              <a:t>…　20260825　20260826　20260827　20260828　…</a:t>
             </a:r>
           </a:p>
           <a:p>
@@ -15612,7 +15725,7 @@
                 </a:solidFill>
                 <a:latin typeface="Consolas"/>
               </a:rPr>
-              <a:t>Stock_Summary/20260828_StockSummary.txt</a:t>
+              <a:t>Stock_Summary/20260831_StockWeeklySummary.txt</a:t>
             </a:r>
           </a:p>
           <a:p>
@@ -15631,7 +15744,7 @@
                 </a:solidFill>
                 <a:latin typeface="Microsoft JhengHei"/>
               </a:rPr>
-              <a:t>每份為當日多支財經節目的彙整摘要，五份合計約 12 萬字。</a:t>
+              <a:t>五個交易日各一份，加上 08/29–08/30 週末節目一份，合計約 13 萬字。</a:t>
             </a:r>
           </a:p>
         </p:txBody>
@@ -16189,7 +16302,7 @@
                 </a:solidFill>
                 <a:latin typeface="Microsoft JhengHei"/>
               </a:rPr>
-              <a:t>08/28 的來源檔在最後一位分析師的個股段落中斷（新盛力 3211 之後無內容），該段未納入本簡報</a:t>
+              <a:t>來源檔在 08/25 寫「蔡明漢」、08/26 寫「蔡明翰」，經確認為同一人，正確為蔡明翰，本簡報已統一</a:t>
             </a:r>
           </a:p>
         </p:txBody>
@@ -16319,7 +16432,7 @@
                 </a:solidFill>
                 <a:latin typeface="Microsoft JhengHei"/>
               </a:rPr>
-              <a:t>來源檔在 08/25 寫「蔡明漢」、08/26 寫「蔡明翰」，經確認為同一人，正確為蔡明翰，本簡報已統一</a:t>
+              <a:t>週末那份來源檔內文帶有 [40, 55] 這類行號標記，是產生摘要時留下的，本簡報整理時一律忽略</a:t>
             </a:r>
           </a:p>
         </p:txBody>
@@ -16659,7 +16772,7 @@
                 </a:solidFill>
                 <a:latin typeface="Microsoft JhengHei"/>
               </a:rPr>
-              <a:t>2026/08/24 – 08/28　台股財經節目週摘要　·　Generated with Claude Code</a:t>
+              <a:t>2026/08/24 – 08/30　台股財經節目週摘要　·　Generated with Claude Code</a:t>
             </a:r>
           </a:p>
         </p:txBody>

</xml_diff>